<commit_message>
deck: add model-agnostic slide + update competitive comparison
New slide 7: 'Memory outlives your model choice'
- Model agnostic: Claude → GPT → Gemini
- Cross-platform: Telegram, Discord, Slack, Web
- Cross-device: cloud-native, survives restarts

Updated competitive table:
- Added 'Model lock-in' row
- Added 'Cross-platform' row

Key message: ChatGPT memory is locked to OpenAI. Engrm memory is yours.
</commit_message>
<xml_diff>
--- a/Engrm-Pitch-Deck-v3.pptx
+++ b/Engrm-Pitch-Deck-v3.pptx
@@ -16,6 +16,7 @@
     <p:sldId id="264" r:id="rId15"/>
     <p:sldId id="265" r:id="rId16"/>
     <p:sldId id="266" r:id="rId17"/>
+    <p:sldId id="267" r:id="rId18"/>
   </p:sldIdLst>
   <p:sldSz cx="14630400" cy="8229600" type="screen4x3"/>
   <p:notesSz cx="6858000" cy="9144000"/>
@@ -3464,57 +3465,170 @@
               </a:defRPr>
             </a:pPr>
             <a:r>
-              <a:t>Simple pricing</a:t>
-            </a:r>
-          </a:p>
-        </p:txBody>
-      </p:sp>
-      <p:sp>
-        <p:nvSpPr>
-          <p:cNvPr id="4" name="TextBox 3"/>
-          <p:cNvSpPr txBox="1"/>
-          <p:nvPr/>
-        </p:nvSpPr>
-        <p:spPr>
-          <a:xfrm>
-            <a:off x="1097280" y="2377440"/>
-            <a:ext cx="7315200" cy="457200"/>
-          </a:xfrm>
-          <a:prstGeom prst="rect">
-            <a:avLst/>
-          </a:prstGeom>
-          <a:noFill/>
-        </p:spPr>
-        <p:txBody>
-          <a:bodyPr wrap="square">
-            <a:spAutoFit/>
-          </a:bodyPr>
-          <a:lstStyle/>
-          <a:p>
-            <a:pPr algn="l">
-              <a:defRPr sz="2000" b="0">
-                <a:solidFill>
-                  <a:srgbClr val="1E1E1E"/>
+              <a:t>Status &amp; roadmap</a:t>
+            </a:r>
+          </a:p>
+        </p:txBody>
+      </p:sp>
+      <p:sp>
+        <p:nvSpPr>
+          <p:cNvPr id="4" name="Rounded Rectangle 3"/>
+          <p:cNvSpPr/>
+          <p:nvPr/>
+        </p:nvSpPr>
+        <p:spPr>
+          <a:xfrm>
+            <a:off x="1097280" y="2743200"/>
+            <a:ext cx="6400800" cy="4114800"/>
+          </a:xfrm>
+          <a:prstGeom prst="roundRect">
+            <a:avLst>
+              <a:gd name="adj" fmla="val 5000"/>
+            </a:avLst>
+          </a:prstGeom>
+          <a:solidFill>
+            <a:srgbClr val="000000"/>
+          </a:solidFill>
+          <a:ln>
+            <a:noFill/>
+          </a:ln>
+        </p:spPr>
+        <p:style>
+          <a:lnRef idx="1">
+            <a:schemeClr val="accent1"/>
+          </a:lnRef>
+          <a:fillRef idx="3">
+            <a:schemeClr val="accent1"/>
+          </a:fillRef>
+          <a:effectRef idx="2">
+            <a:schemeClr val="accent1"/>
+          </a:effectRef>
+          <a:fontRef idx="minor">
+            <a:schemeClr val="lt1"/>
+          </a:fontRef>
+        </p:style>
+        <p:txBody>
+          <a:bodyPr rtlCol="0" anchor="ctr"/>
+          <a:lstStyle/>
+          <a:p>
+            <a:pPr algn="ctr"/>
+          </a:p>
+        </p:txBody>
+      </p:sp>
+      <p:sp>
+        <p:nvSpPr>
+          <p:cNvPr id="5" name="TextBox 4"/>
+          <p:cNvSpPr txBox="1"/>
+          <p:nvPr/>
+        </p:nvSpPr>
+        <p:spPr>
+          <a:xfrm>
+            <a:off x="1371600" y="2926080"/>
+            <a:ext cx="5486400" cy="457200"/>
+          </a:xfrm>
+          <a:prstGeom prst="rect">
+            <a:avLst/>
+          </a:prstGeom>
+          <a:noFill/>
+        </p:spPr>
+        <p:txBody>
+          <a:bodyPr wrap="square">
+            <a:spAutoFit/>
+          </a:bodyPr>
+          <a:lstStyle/>
+          <a:p>
+            <a:pPr algn="l">
+              <a:defRPr sz="1800" b="1">
+                <a:solidFill>
+                  <a:srgbClr val="FFDB15"/>
                 </a:solidFill>
                 <a:latin typeface="Arial"/>
               </a:defRPr>
             </a:pPr>
             <a:r>
-              <a:t>Start free. Scale with usage.</a:t>
-            </a:r>
-          </a:p>
-        </p:txBody>
-      </p:sp>
-      <p:sp>
-        <p:nvSpPr>
-          <p:cNvPr id="5" name="Rounded Rectangle 4"/>
+              <a:t>Live in production</a:t>
+            </a:r>
+          </a:p>
+        </p:txBody>
+      </p:sp>
+      <p:sp>
+        <p:nvSpPr>
+          <p:cNvPr id="6" name="TextBox 5"/>
+          <p:cNvSpPr txBox="1"/>
+          <p:nvPr/>
+        </p:nvSpPr>
+        <p:spPr>
+          <a:xfrm>
+            <a:off x="1371600" y="3474720"/>
+            <a:ext cx="5943600" cy="3200400"/>
+          </a:xfrm>
+          <a:prstGeom prst="rect">
+            <a:avLst/>
+          </a:prstGeom>
+          <a:noFill/>
+        </p:spPr>
+        <p:txBody>
+          <a:bodyPr wrap="square">
+            <a:spAutoFit/>
+          </a:bodyPr>
+          <a:lstStyle/>
+          <a:p>
+            <a:pPr algn="l">
+              <a:defRPr sz="1300" b="0">
+                <a:solidFill>
+                  <a:srgbClr val="FFFFFF"/>
+                </a:solidFill>
+                <a:latin typeface="Arial"/>
+              </a:defRPr>
+            </a:pPr>
+            <a:r>
+              <a:t>✓ Core API (store, search, context)</a:t>
+            </a:r>
+            <a:br/>
+            <a:r>
+              <a:t>✓ Server-side encryption (AES-256-GCM)</a:t>
+            </a:r>
+            <a:br/>
+            <a:r>
+              <a:t>✓ Memory types &amp; classification</a:t>
+            </a:r>
+            <a:br/>
+            <a:r>
+              <a:t>✓ Tiered importance system</a:t>
+            </a:r>
+            <a:br/>
+            <a:r>
+              <a:t>✓ Reflect, consolidate, decay</a:t>
+            </a:r>
+            <a:br/>
+            <a:r>
+              <a:t>✓ Entity extraction &amp; linking</a:t>
+            </a:r>
+            <a:br/>
+            <a:r>
+              <a:t>✓ Memory Browser dashboard</a:t>
+            </a:r>
+            <a:br/>
+            <a:r>
+              <a:t>✓ Python SDK + MCP server</a:t>
+            </a:r>
+            <a:br/>
+            <a:r>
+              <a:t>✓ LongMemEval benchmark integration</a:t>
+            </a:r>
+          </a:p>
+        </p:txBody>
+      </p:sp>
+      <p:sp>
+        <p:nvSpPr>
+          <p:cNvPr id="7" name="Rounded Rectangle 6"/>
           <p:cNvSpPr/>
           <p:nvPr/>
         </p:nvSpPr>
         <p:spPr>
           <a:xfrm>
-            <a:off x="1097280" y="3200400"/>
-            <a:ext cx="4114800" cy="3840480"/>
+            <a:off x="7955279" y="2743200"/>
+            <a:ext cx="5486400" cy="4114800"/>
           </a:xfrm>
           <a:prstGeom prst="roundRect">
             <a:avLst>
@@ -3552,457 +3666,103 @@
       </p:sp>
       <p:sp>
         <p:nvSpPr>
-          <p:cNvPr id="6" name="TextBox 5"/>
-          <p:cNvSpPr txBox="1"/>
-          <p:nvPr/>
-        </p:nvSpPr>
-        <p:spPr>
-          <a:xfrm>
-            <a:off x="1371600" y="3474720"/>
-            <a:ext cx="3657600" cy="365760"/>
-          </a:xfrm>
-          <a:prstGeom prst="rect">
-            <a:avLst/>
-          </a:prstGeom>
-          <a:noFill/>
-        </p:spPr>
-        <p:txBody>
-          <a:bodyPr wrap="square">
-            <a:spAutoFit/>
-          </a:bodyPr>
-          <a:lstStyle/>
-          <a:p>
-            <a:pPr algn="l">
-              <a:defRPr sz="1200" b="1">
+          <p:cNvPr id="8" name="TextBox 7"/>
+          <p:cNvSpPr txBox="1"/>
+          <p:nvPr/>
+        </p:nvSpPr>
+        <p:spPr>
+          <a:xfrm>
+            <a:off x="8229600" y="2926080"/>
+            <a:ext cx="5029200" cy="457200"/>
+          </a:xfrm>
+          <a:prstGeom prst="rect">
+            <a:avLst/>
+          </a:prstGeom>
+          <a:noFill/>
+        </p:spPr>
+        <p:txBody>
+          <a:bodyPr wrap="square">
+            <a:spAutoFit/>
+          </a:bodyPr>
+          <a:lstStyle/>
+          <a:p>
+            <a:pPr algn="l">
+              <a:defRPr sz="1800" b="1">
+                <a:solidFill>
+                  <a:srgbClr val="FFFFFF"/>
+                </a:solidFill>
+                <a:latin typeface="Arial"/>
+              </a:defRPr>
+            </a:pPr>
+            <a:r>
+              <a:t>Next 90 days</a:t>
+            </a:r>
+          </a:p>
+        </p:txBody>
+      </p:sp>
+      <p:sp>
+        <p:nvSpPr>
+          <p:cNvPr id="9" name="TextBox 8"/>
+          <p:cNvSpPr txBox="1"/>
+          <p:nvPr/>
+        </p:nvSpPr>
+        <p:spPr>
+          <a:xfrm>
+            <a:off x="8229600" y="3474720"/>
+            <a:ext cx="5029200" cy="3200400"/>
+          </a:xfrm>
+          <a:prstGeom prst="rect">
+            <a:avLst/>
+          </a:prstGeom>
+          <a:noFill/>
+        </p:spPr>
+        <p:txBody>
+          <a:bodyPr wrap="square">
+            <a:spAutoFit/>
+          </a:bodyPr>
+          <a:lstStyle/>
+          <a:p>
+            <a:pPr algn="l">
+              <a:defRPr sz="1300" b="0">
                 <a:solidFill>
                   <a:srgbClr val="646464"/>
                 </a:solidFill>
-                <a:latin typeface="Consolas"/>
-              </a:defRPr>
-            </a:pPr>
-            <a:r>
-              <a:t>FREE</a:t>
-            </a:r>
-          </a:p>
-        </p:txBody>
-      </p:sp>
-      <p:sp>
-        <p:nvSpPr>
-          <p:cNvPr id="7" name="TextBox 6"/>
-          <p:cNvSpPr txBox="1"/>
-          <p:nvPr/>
-        </p:nvSpPr>
-        <p:spPr>
-          <a:xfrm>
-            <a:off x="1371600" y="3931920"/>
-            <a:ext cx="3657600" cy="640080"/>
-          </a:xfrm>
-          <a:prstGeom prst="rect">
-            <a:avLst/>
-          </a:prstGeom>
-          <a:noFill/>
-        </p:spPr>
-        <p:txBody>
-          <a:bodyPr wrap="square">
-            <a:spAutoFit/>
-          </a:bodyPr>
-          <a:lstStyle/>
-          <a:p>
-            <a:pPr algn="l">
-              <a:defRPr sz="4400" b="1">
-                <a:solidFill>
-                  <a:srgbClr val="FFFFFF"/>
-                </a:solidFill>
                 <a:latin typeface="Arial"/>
               </a:defRPr>
             </a:pPr>
             <a:r>
-              <a:t>$0</a:t>
-            </a:r>
-          </a:p>
-        </p:txBody>
-      </p:sp>
-      <p:sp>
-        <p:nvSpPr>
-          <p:cNvPr id="8" name="TextBox 7"/>
-          <p:cNvSpPr txBox="1"/>
-          <p:nvPr/>
-        </p:nvSpPr>
-        <p:spPr>
-          <a:xfrm>
-            <a:off x="1371600" y="4754880"/>
-            <a:ext cx="3657600" cy="2011680"/>
-          </a:xfrm>
-          <a:prstGeom prst="rect">
-            <a:avLst/>
-          </a:prstGeom>
-          <a:noFill/>
-        </p:spPr>
-        <p:txBody>
-          <a:bodyPr wrap="square">
-            <a:spAutoFit/>
-          </a:bodyPr>
-          <a:lstStyle/>
-          <a:p>
-            <a:pPr algn="l">
-              <a:defRPr sz="1300" b="0">
-                <a:solidFill>
-                  <a:srgbClr val="646464"/>
-                </a:solidFill>
-                <a:latin typeface="Arial"/>
-              </a:defRPr>
-            </a:pPr>
-            <a:r>
-              <a:t>5K memories/mo</a:t>
+              <a:t>→ LangChain integration</a:t>
             </a:r>
             <a:br/>
             <a:r>
-              <a:t>100MB storage</a:t>
+              <a:t>→ OpenAI Agents SDK adapter</a:t>
             </a:r>
             <a:br/>
             <a:r>
-              <a:t>Core features</a:t>
+              <a:t>→ Proactive recall (auto-surface)</a:t>
             </a:r>
             <a:br/>
             <a:r>
-              <a:t>Community support</a:t>
-            </a:r>
-          </a:p>
-        </p:txBody>
-      </p:sp>
-      <p:sp>
-        <p:nvSpPr>
-          <p:cNvPr id="9" name="Rounded Rectangle 8"/>
-          <p:cNvSpPr/>
-          <p:nvPr/>
-        </p:nvSpPr>
-        <p:spPr>
-          <a:xfrm>
-            <a:off x="5669280" y="3200400"/>
-            <a:ext cx="4114800" cy="3840480"/>
-          </a:xfrm>
-          <a:prstGeom prst="roundRect">
-            <a:avLst>
-              <a:gd name="adj" fmla="val 5000"/>
-            </a:avLst>
-          </a:prstGeom>
-          <a:solidFill>
-            <a:srgbClr val="000000"/>
-          </a:solidFill>
-          <a:ln>
-            <a:noFill/>
-          </a:ln>
-        </p:spPr>
-        <p:style>
-          <a:lnRef idx="1">
-            <a:schemeClr val="accent1"/>
-          </a:lnRef>
-          <a:fillRef idx="3">
-            <a:schemeClr val="accent1"/>
-          </a:fillRef>
-          <a:effectRef idx="2">
-            <a:schemeClr val="accent1"/>
-          </a:effectRef>
-          <a:fontRef idx="minor">
-            <a:schemeClr val="lt1"/>
-          </a:fontRef>
-        </p:style>
-        <p:txBody>
-          <a:bodyPr rtlCol="0" anchor="ctr"/>
-          <a:lstStyle/>
-          <a:p>
-            <a:pPr algn="ctr"/>
+              <a:t>→ Contradiction detection</a:t>
+            </a:r>
+            <a:br/>
+            <a:r>
+              <a:t>→ Multi-agent memory sharing</a:t>
+            </a:r>
+            <a:br/>
+            <a:r>
+              <a:t>→ Enterprise SSO + audit logs</a:t>
+            </a:r>
+            <a:br/>
+            <a:r>
+              <a:t>→ On-prem deployment option</a:t>
+            </a:r>
           </a:p>
         </p:txBody>
       </p:sp>
       <p:sp>
         <p:nvSpPr>
           <p:cNvPr id="10" name="TextBox 9"/>
-          <p:cNvSpPr txBox="1"/>
-          <p:nvPr/>
-        </p:nvSpPr>
-        <p:spPr>
-          <a:xfrm>
-            <a:off x="5943600" y="3474720"/>
-            <a:ext cx="3657600" cy="365760"/>
-          </a:xfrm>
-          <a:prstGeom prst="rect">
-            <a:avLst/>
-          </a:prstGeom>
-          <a:noFill/>
-        </p:spPr>
-        <p:txBody>
-          <a:bodyPr wrap="square">
-            <a:spAutoFit/>
-          </a:bodyPr>
-          <a:lstStyle/>
-          <a:p>
-            <a:pPr algn="l">
-              <a:defRPr sz="1200" b="1">
-                <a:solidFill>
-                  <a:srgbClr val="FFDB15"/>
-                </a:solidFill>
-                <a:latin typeface="Consolas"/>
-              </a:defRPr>
-            </a:pPr>
-            <a:r>
-              <a:t>PRO</a:t>
-            </a:r>
-          </a:p>
-        </p:txBody>
-      </p:sp>
-      <p:sp>
-        <p:nvSpPr>
-          <p:cNvPr id="11" name="TextBox 10"/>
-          <p:cNvSpPr txBox="1"/>
-          <p:nvPr/>
-        </p:nvSpPr>
-        <p:spPr>
-          <a:xfrm>
-            <a:off x="5943600" y="3931920"/>
-            <a:ext cx="3657600" cy="640080"/>
-          </a:xfrm>
-          <a:prstGeom prst="rect">
-            <a:avLst/>
-          </a:prstGeom>
-          <a:noFill/>
-        </p:spPr>
-        <p:txBody>
-          <a:bodyPr wrap="square">
-            <a:spAutoFit/>
-          </a:bodyPr>
-          <a:lstStyle/>
-          <a:p>
-            <a:pPr algn="l">
-              <a:defRPr sz="4400" b="1">
-                <a:solidFill>
-                  <a:srgbClr val="FFDB15"/>
-                </a:solidFill>
-                <a:latin typeface="Arial"/>
-              </a:defRPr>
-            </a:pPr>
-            <a:r>
-              <a:t>$29</a:t>
-            </a:r>
-          </a:p>
-        </p:txBody>
-      </p:sp>
-      <p:sp>
-        <p:nvSpPr>
-          <p:cNvPr id="12" name="TextBox 11"/>
-          <p:cNvSpPr txBox="1"/>
-          <p:nvPr/>
-        </p:nvSpPr>
-        <p:spPr>
-          <a:xfrm>
-            <a:off x="5943600" y="4754880"/>
-            <a:ext cx="3657600" cy="2011680"/>
-          </a:xfrm>
-          <a:prstGeom prst="rect">
-            <a:avLst/>
-          </a:prstGeom>
-          <a:noFill/>
-        </p:spPr>
-        <p:txBody>
-          <a:bodyPr wrap="square">
-            <a:spAutoFit/>
-          </a:bodyPr>
-          <a:lstStyle/>
-          <a:p>
-            <a:pPr algn="l">
-              <a:defRPr sz="1300" b="0">
-                <a:solidFill>
-                  <a:srgbClr val="FFFFFF"/>
-                </a:solidFill>
-                <a:latin typeface="Arial"/>
-              </a:defRPr>
-            </a:pPr>
-            <a:r>
-              <a:t>50K memories/mo</a:t>
-            </a:r>
-            <a:br/>
-            <a:r>
-              <a:t>1GB storage</a:t>
-            </a:r>
-            <a:br/>
-            <a:r>
-              <a:t>Reflect &amp; analytics</a:t>
-            </a:r>
-            <a:br/>
-            <a:r>
-              <a:t>Priority support</a:t>
-            </a:r>
-          </a:p>
-        </p:txBody>
-      </p:sp>
-      <p:sp>
-        <p:nvSpPr>
-          <p:cNvPr id="13" name="Rounded Rectangle 12"/>
-          <p:cNvSpPr/>
-          <p:nvPr/>
-        </p:nvSpPr>
-        <p:spPr>
-          <a:xfrm>
-            <a:off x="10241280" y="3200400"/>
-            <a:ext cx="4114800" cy="3840480"/>
-          </a:xfrm>
-          <a:prstGeom prst="roundRect">
-            <a:avLst>
-              <a:gd name="adj" fmla="val 5000"/>
-            </a:avLst>
-          </a:prstGeom>
-          <a:solidFill>
-            <a:srgbClr val="1E1E1E"/>
-          </a:solidFill>
-          <a:ln>
-            <a:noFill/>
-          </a:ln>
-        </p:spPr>
-        <p:style>
-          <a:lnRef idx="1">
-            <a:schemeClr val="accent1"/>
-          </a:lnRef>
-          <a:fillRef idx="3">
-            <a:schemeClr val="accent1"/>
-          </a:fillRef>
-          <a:effectRef idx="2">
-            <a:schemeClr val="accent1"/>
-          </a:effectRef>
-          <a:fontRef idx="minor">
-            <a:schemeClr val="lt1"/>
-          </a:fontRef>
-        </p:style>
-        <p:txBody>
-          <a:bodyPr rtlCol="0" anchor="ctr"/>
-          <a:lstStyle/>
-          <a:p>
-            <a:pPr algn="ctr"/>
-          </a:p>
-        </p:txBody>
-      </p:sp>
-      <p:sp>
-        <p:nvSpPr>
-          <p:cNvPr id="14" name="TextBox 13"/>
-          <p:cNvSpPr txBox="1"/>
-          <p:nvPr/>
-        </p:nvSpPr>
-        <p:spPr>
-          <a:xfrm>
-            <a:off x="10515600" y="3474720"/>
-            <a:ext cx="3657600" cy="365760"/>
-          </a:xfrm>
-          <a:prstGeom prst="rect">
-            <a:avLst/>
-          </a:prstGeom>
-          <a:noFill/>
-        </p:spPr>
-        <p:txBody>
-          <a:bodyPr wrap="square">
-            <a:spAutoFit/>
-          </a:bodyPr>
-          <a:lstStyle/>
-          <a:p>
-            <a:pPr algn="l">
-              <a:defRPr sz="1200" b="1">
-                <a:solidFill>
-                  <a:srgbClr val="646464"/>
-                </a:solidFill>
-                <a:latin typeface="Consolas"/>
-              </a:defRPr>
-            </a:pPr>
-            <a:r>
-              <a:t>ENTERPRISE</a:t>
-            </a:r>
-          </a:p>
-        </p:txBody>
-      </p:sp>
-      <p:sp>
-        <p:nvSpPr>
-          <p:cNvPr id="15" name="TextBox 14"/>
-          <p:cNvSpPr txBox="1"/>
-          <p:nvPr/>
-        </p:nvSpPr>
-        <p:spPr>
-          <a:xfrm>
-            <a:off x="10515600" y="3931920"/>
-            <a:ext cx="3657600" cy="640080"/>
-          </a:xfrm>
-          <a:prstGeom prst="rect">
-            <a:avLst/>
-          </a:prstGeom>
-          <a:noFill/>
-        </p:spPr>
-        <p:txBody>
-          <a:bodyPr wrap="square">
-            <a:spAutoFit/>
-          </a:bodyPr>
-          <a:lstStyle/>
-          <a:p>
-            <a:pPr algn="l">
-              <a:defRPr sz="4400" b="1">
-                <a:solidFill>
-                  <a:srgbClr val="FFFFFF"/>
-                </a:solidFill>
-                <a:latin typeface="Arial"/>
-              </a:defRPr>
-            </a:pPr>
-            <a:r>
-              <a:t>Custom</a:t>
-            </a:r>
-          </a:p>
-        </p:txBody>
-      </p:sp>
-      <p:sp>
-        <p:nvSpPr>
-          <p:cNvPr id="16" name="TextBox 15"/>
-          <p:cNvSpPr txBox="1"/>
-          <p:nvPr/>
-        </p:nvSpPr>
-        <p:spPr>
-          <a:xfrm>
-            <a:off x="10515600" y="4754880"/>
-            <a:ext cx="3657600" cy="2011680"/>
-          </a:xfrm>
-          <a:prstGeom prst="rect">
-            <a:avLst/>
-          </a:prstGeom>
-          <a:noFill/>
-        </p:spPr>
-        <p:txBody>
-          <a:bodyPr wrap="square">
-            <a:spAutoFit/>
-          </a:bodyPr>
-          <a:lstStyle/>
-          <a:p>
-            <a:pPr algn="l">
-              <a:defRPr sz="1300" b="0">
-                <a:solidFill>
-                  <a:srgbClr val="646464"/>
-                </a:solidFill>
-                <a:latin typeface="Arial"/>
-              </a:defRPr>
-            </a:pPr>
-            <a:r>
-              <a:t>Unlimited scale</a:t>
-            </a:r>
-            <a:br/>
-            <a:r>
-              <a:t>On-prem option</a:t>
-            </a:r>
-            <a:br/>
-            <a:r>
-              <a:t>SSO + SLA</a:t>
-            </a:r>
-            <a:br/>
-            <a:r>
-              <a:t>Dedicated support</a:t>
-            </a:r>
-          </a:p>
-        </p:txBody>
-      </p:sp>
-      <p:sp>
-        <p:nvSpPr>
-          <p:cNvPr id="17" name="TextBox 16"/>
           <p:cNvSpPr txBox="1"/>
           <p:nvPr/>
         </p:nvSpPr>
@@ -4031,7 +3791,7 @@
               </a:defRPr>
             </a:pPr>
             <a:r>
-              <a:t>10</a:t>
+              <a:t>11</a:t>
             </a:r>
           </a:p>
         </p:txBody>
@@ -4069,7 +3829,7 @@
             <a:avLst/>
           </a:prstGeom>
           <a:solidFill>
-            <a:srgbClr val="000000"/>
+            <a:srgbClr val="FFDB15"/>
           </a:solidFill>
           <a:ln>
             <a:noFill/>
@@ -4099,17 +3859,91 @@
       </p:sp>
       <p:sp>
         <p:nvSpPr>
-          <p:cNvPr id="3" name="Oval 2"/>
+          <p:cNvPr id="3" name="TextBox 2"/>
+          <p:cNvSpPr txBox="1"/>
+          <p:nvPr/>
+        </p:nvSpPr>
+        <p:spPr>
+          <a:xfrm>
+            <a:off x="1097280" y="1371600"/>
+            <a:ext cx="9144000" cy="914400"/>
+          </a:xfrm>
+          <a:prstGeom prst="rect">
+            <a:avLst/>
+          </a:prstGeom>
+          <a:noFill/>
+        </p:spPr>
+        <p:txBody>
+          <a:bodyPr wrap="square">
+            <a:spAutoFit/>
+          </a:bodyPr>
+          <a:lstStyle/>
+          <a:p>
+            <a:pPr algn="l">
+              <a:defRPr sz="4800" b="1">
+                <a:solidFill>
+                  <a:srgbClr val="000000"/>
+                </a:solidFill>
+                <a:latin typeface="Arial"/>
+              </a:defRPr>
+            </a:pPr>
+            <a:r>
+              <a:t>Simple pricing</a:t>
+            </a:r>
+          </a:p>
+        </p:txBody>
+      </p:sp>
+      <p:sp>
+        <p:nvSpPr>
+          <p:cNvPr id="4" name="TextBox 3"/>
+          <p:cNvSpPr txBox="1"/>
+          <p:nvPr/>
+        </p:nvSpPr>
+        <p:spPr>
+          <a:xfrm>
+            <a:off x="1097280" y="2377440"/>
+            <a:ext cx="7315200" cy="457200"/>
+          </a:xfrm>
+          <a:prstGeom prst="rect">
+            <a:avLst/>
+          </a:prstGeom>
+          <a:noFill/>
+        </p:spPr>
+        <p:txBody>
+          <a:bodyPr wrap="square">
+            <a:spAutoFit/>
+          </a:bodyPr>
+          <a:lstStyle/>
+          <a:p>
+            <a:pPr algn="l">
+              <a:defRPr sz="2000" b="0">
+                <a:solidFill>
+                  <a:srgbClr val="1E1E1E"/>
+                </a:solidFill>
+                <a:latin typeface="Arial"/>
+              </a:defRPr>
+            </a:pPr>
+            <a:r>
+              <a:t>Start free. Scale with usage.</a:t>
+            </a:r>
+          </a:p>
+        </p:txBody>
+      </p:sp>
+      <p:sp>
+        <p:nvSpPr>
+          <p:cNvPr id="5" name="Rounded Rectangle 4"/>
           <p:cNvSpPr/>
           <p:nvPr/>
         </p:nvSpPr>
         <p:spPr>
           <a:xfrm>
-            <a:off x="8229600" y="1828800"/>
-            <a:ext cx="6400800" cy="6400800"/>
-          </a:xfrm>
-          <a:prstGeom prst="ellipse">
-            <a:avLst/>
+            <a:off x="1097280" y="3200400"/>
+            <a:ext cx="4114800" cy="3840480"/>
+          </a:xfrm>
+          <a:prstGeom prst="roundRect">
+            <a:avLst>
+              <a:gd name="adj" fmla="val 5000"/>
+            </a:avLst>
           </a:prstGeom>
           <a:solidFill>
             <a:srgbClr val="1E1E1E"/>
@@ -4142,6 +3976,596 @@
       </p:sp>
       <p:sp>
         <p:nvSpPr>
+          <p:cNvPr id="6" name="TextBox 5"/>
+          <p:cNvSpPr txBox="1"/>
+          <p:nvPr/>
+        </p:nvSpPr>
+        <p:spPr>
+          <a:xfrm>
+            <a:off x="1371600" y="3474720"/>
+            <a:ext cx="3657600" cy="365760"/>
+          </a:xfrm>
+          <a:prstGeom prst="rect">
+            <a:avLst/>
+          </a:prstGeom>
+          <a:noFill/>
+        </p:spPr>
+        <p:txBody>
+          <a:bodyPr wrap="square">
+            <a:spAutoFit/>
+          </a:bodyPr>
+          <a:lstStyle/>
+          <a:p>
+            <a:pPr algn="l">
+              <a:defRPr sz="1200" b="1">
+                <a:solidFill>
+                  <a:srgbClr val="646464"/>
+                </a:solidFill>
+                <a:latin typeface="Consolas"/>
+              </a:defRPr>
+            </a:pPr>
+            <a:r>
+              <a:t>FREE</a:t>
+            </a:r>
+          </a:p>
+        </p:txBody>
+      </p:sp>
+      <p:sp>
+        <p:nvSpPr>
+          <p:cNvPr id="7" name="TextBox 6"/>
+          <p:cNvSpPr txBox="1"/>
+          <p:nvPr/>
+        </p:nvSpPr>
+        <p:spPr>
+          <a:xfrm>
+            <a:off x="1371600" y="3931920"/>
+            <a:ext cx="3657600" cy="640080"/>
+          </a:xfrm>
+          <a:prstGeom prst="rect">
+            <a:avLst/>
+          </a:prstGeom>
+          <a:noFill/>
+        </p:spPr>
+        <p:txBody>
+          <a:bodyPr wrap="square">
+            <a:spAutoFit/>
+          </a:bodyPr>
+          <a:lstStyle/>
+          <a:p>
+            <a:pPr algn="l">
+              <a:defRPr sz="4400" b="1">
+                <a:solidFill>
+                  <a:srgbClr val="FFFFFF"/>
+                </a:solidFill>
+                <a:latin typeface="Arial"/>
+              </a:defRPr>
+            </a:pPr>
+            <a:r>
+              <a:t>$0</a:t>
+            </a:r>
+          </a:p>
+        </p:txBody>
+      </p:sp>
+      <p:sp>
+        <p:nvSpPr>
+          <p:cNvPr id="8" name="TextBox 7"/>
+          <p:cNvSpPr txBox="1"/>
+          <p:nvPr/>
+        </p:nvSpPr>
+        <p:spPr>
+          <a:xfrm>
+            <a:off x="1371600" y="4754880"/>
+            <a:ext cx="3657600" cy="2011680"/>
+          </a:xfrm>
+          <a:prstGeom prst="rect">
+            <a:avLst/>
+          </a:prstGeom>
+          <a:noFill/>
+        </p:spPr>
+        <p:txBody>
+          <a:bodyPr wrap="square">
+            <a:spAutoFit/>
+          </a:bodyPr>
+          <a:lstStyle/>
+          <a:p>
+            <a:pPr algn="l">
+              <a:defRPr sz="1300" b="0">
+                <a:solidFill>
+                  <a:srgbClr val="646464"/>
+                </a:solidFill>
+                <a:latin typeface="Arial"/>
+              </a:defRPr>
+            </a:pPr>
+            <a:r>
+              <a:t>5K memories/mo</a:t>
+            </a:r>
+            <a:br/>
+            <a:r>
+              <a:t>100MB storage</a:t>
+            </a:r>
+            <a:br/>
+            <a:r>
+              <a:t>Core features</a:t>
+            </a:r>
+            <a:br/>
+            <a:r>
+              <a:t>Community support</a:t>
+            </a:r>
+          </a:p>
+        </p:txBody>
+      </p:sp>
+      <p:sp>
+        <p:nvSpPr>
+          <p:cNvPr id="9" name="Rounded Rectangle 8"/>
+          <p:cNvSpPr/>
+          <p:nvPr/>
+        </p:nvSpPr>
+        <p:spPr>
+          <a:xfrm>
+            <a:off x="5669280" y="3200400"/>
+            <a:ext cx="4114800" cy="3840480"/>
+          </a:xfrm>
+          <a:prstGeom prst="roundRect">
+            <a:avLst>
+              <a:gd name="adj" fmla="val 5000"/>
+            </a:avLst>
+          </a:prstGeom>
+          <a:solidFill>
+            <a:srgbClr val="000000"/>
+          </a:solidFill>
+          <a:ln>
+            <a:noFill/>
+          </a:ln>
+        </p:spPr>
+        <p:style>
+          <a:lnRef idx="1">
+            <a:schemeClr val="accent1"/>
+          </a:lnRef>
+          <a:fillRef idx="3">
+            <a:schemeClr val="accent1"/>
+          </a:fillRef>
+          <a:effectRef idx="2">
+            <a:schemeClr val="accent1"/>
+          </a:effectRef>
+          <a:fontRef idx="minor">
+            <a:schemeClr val="lt1"/>
+          </a:fontRef>
+        </p:style>
+        <p:txBody>
+          <a:bodyPr rtlCol="0" anchor="ctr"/>
+          <a:lstStyle/>
+          <a:p>
+            <a:pPr algn="ctr"/>
+          </a:p>
+        </p:txBody>
+      </p:sp>
+      <p:sp>
+        <p:nvSpPr>
+          <p:cNvPr id="10" name="TextBox 9"/>
+          <p:cNvSpPr txBox="1"/>
+          <p:nvPr/>
+        </p:nvSpPr>
+        <p:spPr>
+          <a:xfrm>
+            <a:off x="5943600" y="3474720"/>
+            <a:ext cx="3657600" cy="365760"/>
+          </a:xfrm>
+          <a:prstGeom prst="rect">
+            <a:avLst/>
+          </a:prstGeom>
+          <a:noFill/>
+        </p:spPr>
+        <p:txBody>
+          <a:bodyPr wrap="square">
+            <a:spAutoFit/>
+          </a:bodyPr>
+          <a:lstStyle/>
+          <a:p>
+            <a:pPr algn="l">
+              <a:defRPr sz="1200" b="1">
+                <a:solidFill>
+                  <a:srgbClr val="FFDB15"/>
+                </a:solidFill>
+                <a:latin typeface="Consolas"/>
+              </a:defRPr>
+            </a:pPr>
+            <a:r>
+              <a:t>PRO</a:t>
+            </a:r>
+          </a:p>
+        </p:txBody>
+      </p:sp>
+      <p:sp>
+        <p:nvSpPr>
+          <p:cNvPr id="11" name="TextBox 10"/>
+          <p:cNvSpPr txBox="1"/>
+          <p:nvPr/>
+        </p:nvSpPr>
+        <p:spPr>
+          <a:xfrm>
+            <a:off x="5943600" y="3931920"/>
+            <a:ext cx="3657600" cy="640080"/>
+          </a:xfrm>
+          <a:prstGeom prst="rect">
+            <a:avLst/>
+          </a:prstGeom>
+          <a:noFill/>
+        </p:spPr>
+        <p:txBody>
+          <a:bodyPr wrap="square">
+            <a:spAutoFit/>
+          </a:bodyPr>
+          <a:lstStyle/>
+          <a:p>
+            <a:pPr algn="l">
+              <a:defRPr sz="4400" b="1">
+                <a:solidFill>
+                  <a:srgbClr val="FFDB15"/>
+                </a:solidFill>
+                <a:latin typeface="Arial"/>
+              </a:defRPr>
+            </a:pPr>
+            <a:r>
+              <a:t>$29</a:t>
+            </a:r>
+          </a:p>
+        </p:txBody>
+      </p:sp>
+      <p:sp>
+        <p:nvSpPr>
+          <p:cNvPr id="12" name="TextBox 11"/>
+          <p:cNvSpPr txBox="1"/>
+          <p:nvPr/>
+        </p:nvSpPr>
+        <p:spPr>
+          <a:xfrm>
+            <a:off x="5943600" y="4754880"/>
+            <a:ext cx="3657600" cy="2011680"/>
+          </a:xfrm>
+          <a:prstGeom prst="rect">
+            <a:avLst/>
+          </a:prstGeom>
+          <a:noFill/>
+        </p:spPr>
+        <p:txBody>
+          <a:bodyPr wrap="square">
+            <a:spAutoFit/>
+          </a:bodyPr>
+          <a:lstStyle/>
+          <a:p>
+            <a:pPr algn="l">
+              <a:defRPr sz="1300" b="0">
+                <a:solidFill>
+                  <a:srgbClr val="FFFFFF"/>
+                </a:solidFill>
+                <a:latin typeface="Arial"/>
+              </a:defRPr>
+            </a:pPr>
+            <a:r>
+              <a:t>50K memories/mo</a:t>
+            </a:r>
+            <a:br/>
+            <a:r>
+              <a:t>1GB storage</a:t>
+            </a:r>
+            <a:br/>
+            <a:r>
+              <a:t>Reflect &amp; analytics</a:t>
+            </a:r>
+            <a:br/>
+            <a:r>
+              <a:t>Priority support</a:t>
+            </a:r>
+          </a:p>
+        </p:txBody>
+      </p:sp>
+      <p:sp>
+        <p:nvSpPr>
+          <p:cNvPr id="13" name="Rounded Rectangle 12"/>
+          <p:cNvSpPr/>
+          <p:nvPr/>
+        </p:nvSpPr>
+        <p:spPr>
+          <a:xfrm>
+            <a:off x="10241280" y="3200400"/>
+            <a:ext cx="4114800" cy="3840480"/>
+          </a:xfrm>
+          <a:prstGeom prst="roundRect">
+            <a:avLst>
+              <a:gd name="adj" fmla="val 5000"/>
+            </a:avLst>
+          </a:prstGeom>
+          <a:solidFill>
+            <a:srgbClr val="1E1E1E"/>
+          </a:solidFill>
+          <a:ln>
+            <a:noFill/>
+          </a:ln>
+        </p:spPr>
+        <p:style>
+          <a:lnRef idx="1">
+            <a:schemeClr val="accent1"/>
+          </a:lnRef>
+          <a:fillRef idx="3">
+            <a:schemeClr val="accent1"/>
+          </a:fillRef>
+          <a:effectRef idx="2">
+            <a:schemeClr val="accent1"/>
+          </a:effectRef>
+          <a:fontRef idx="minor">
+            <a:schemeClr val="lt1"/>
+          </a:fontRef>
+        </p:style>
+        <p:txBody>
+          <a:bodyPr rtlCol="0" anchor="ctr"/>
+          <a:lstStyle/>
+          <a:p>
+            <a:pPr algn="ctr"/>
+          </a:p>
+        </p:txBody>
+      </p:sp>
+      <p:sp>
+        <p:nvSpPr>
+          <p:cNvPr id="14" name="TextBox 13"/>
+          <p:cNvSpPr txBox="1"/>
+          <p:nvPr/>
+        </p:nvSpPr>
+        <p:spPr>
+          <a:xfrm>
+            <a:off x="10515600" y="3474720"/>
+            <a:ext cx="3657600" cy="365760"/>
+          </a:xfrm>
+          <a:prstGeom prst="rect">
+            <a:avLst/>
+          </a:prstGeom>
+          <a:noFill/>
+        </p:spPr>
+        <p:txBody>
+          <a:bodyPr wrap="square">
+            <a:spAutoFit/>
+          </a:bodyPr>
+          <a:lstStyle/>
+          <a:p>
+            <a:pPr algn="l">
+              <a:defRPr sz="1200" b="1">
+                <a:solidFill>
+                  <a:srgbClr val="646464"/>
+                </a:solidFill>
+                <a:latin typeface="Consolas"/>
+              </a:defRPr>
+            </a:pPr>
+            <a:r>
+              <a:t>ENTERPRISE</a:t>
+            </a:r>
+          </a:p>
+        </p:txBody>
+      </p:sp>
+      <p:sp>
+        <p:nvSpPr>
+          <p:cNvPr id="15" name="TextBox 14"/>
+          <p:cNvSpPr txBox="1"/>
+          <p:nvPr/>
+        </p:nvSpPr>
+        <p:spPr>
+          <a:xfrm>
+            <a:off x="10515600" y="3931920"/>
+            <a:ext cx="3657600" cy="640080"/>
+          </a:xfrm>
+          <a:prstGeom prst="rect">
+            <a:avLst/>
+          </a:prstGeom>
+          <a:noFill/>
+        </p:spPr>
+        <p:txBody>
+          <a:bodyPr wrap="square">
+            <a:spAutoFit/>
+          </a:bodyPr>
+          <a:lstStyle/>
+          <a:p>
+            <a:pPr algn="l">
+              <a:defRPr sz="4400" b="1">
+                <a:solidFill>
+                  <a:srgbClr val="FFFFFF"/>
+                </a:solidFill>
+                <a:latin typeface="Arial"/>
+              </a:defRPr>
+            </a:pPr>
+            <a:r>
+              <a:t>Custom</a:t>
+            </a:r>
+          </a:p>
+        </p:txBody>
+      </p:sp>
+      <p:sp>
+        <p:nvSpPr>
+          <p:cNvPr id="16" name="TextBox 15"/>
+          <p:cNvSpPr txBox="1"/>
+          <p:nvPr/>
+        </p:nvSpPr>
+        <p:spPr>
+          <a:xfrm>
+            <a:off x="10515600" y="4754880"/>
+            <a:ext cx="3657600" cy="2011680"/>
+          </a:xfrm>
+          <a:prstGeom prst="rect">
+            <a:avLst/>
+          </a:prstGeom>
+          <a:noFill/>
+        </p:spPr>
+        <p:txBody>
+          <a:bodyPr wrap="square">
+            <a:spAutoFit/>
+          </a:bodyPr>
+          <a:lstStyle/>
+          <a:p>
+            <a:pPr algn="l">
+              <a:defRPr sz="1300" b="0">
+                <a:solidFill>
+                  <a:srgbClr val="646464"/>
+                </a:solidFill>
+                <a:latin typeface="Arial"/>
+              </a:defRPr>
+            </a:pPr>
+            <a:r>
+              <a:t>Unlimited scale</a:t>
+            </a:r>
+            <a:br/>
+            <a:r>
+              <a:t>On-prem option</a:t>
+            </a:r>
+            <a:br/>
+            <a:r>
+              <a:t>SSO + SLA</a:t>
+            </a:r>
+            <a:br/>
+            <a:r>
+              <a:t>Dedicated support</a:t>
+            </a:r>
+          </a:p>
+        </p:txBody>
+      </p:sp>
+      <p:sp>
+        <p:nvSpPr>
+          <p:cNvPr id="17" name="TextBox 16"/>
+          <p:cNvSpPr txBox="1"/>
+          <p:nvPr/>
+        </p:nvSpPr>
+        <p:spPr>
+          <a:xfrm>
+            <a:off x="13258800" y="7498079"/>
+            <a:ext cx="1097280" cy="365760"/>
+          </a:xfrm>
+          <a:prstGeom prst="rect">
+            <a:avLst/>
+          </a:prstGeom>
+          <a:noFill/>
+        </p:spPr>
+        <p:txBody>
+          <a:bodyPr wrap="square">
+            <a:spAutoFit/>
+          </a:bodyPr>
+          <a:lstStyle/>
+          <a:p>
+            <a:pPr algn="r">
+              <a:defRPr sz="1100" b="0">
+                <a:solidFill>
+                  <a:srgbClr val="646464"/>
+                </a:solidFill>
+                <a:latin typeface="Consolas"/>
+              </a:defRPr>
+            </a:pPr>
+            <a:r>
+              <a:t>11</a:t>
+            </a:r>
+          </a:p>
+        </p:txBody>
+      </p:sp>
+    </p:spTree>
+  </p:cSld>
+  <p:clrMapOvr>
+    <a:masterClrMapping/>
+  </p:clrMapOvr>
+</p:sld>
+</file>
+
+<file path=ppt/slides/slide12.xml><?xml version="1.0" encoding="utf-8"?>
+<p:sld xmlns:a="http://schemas.openxmlformats.org/drawingml/2006/main" xmlns:p="http://schemas.openxmlformats.org/presentationml/2006/main" xmlns:r="http://schemas.openxmlformats.org/officeDocument/2006/relationships">
+  <p:cSld>
+    <p:spTree>
+      <p:nvGrpSpPr>
+        <p:cNvPr id="1" name=""/>
+        <p:cNvGrpSpPr/>
+        <p:nvPr/>
+      </p:nvGrpSpPr>
+      <p:grpSpPr/>
+      <p:sp>
+        <p:nvSpPr>
+          <p:cNvPr id="2" name="Rectangle 1"/>
+          <p:cNvSpPr/>
+          <p:nvPr/>
+        </p:nvSpPr>
+        <p:spPr>
+          <a:xfrm>
+            <a:off x="0" y="0"/>
+            <a:ext cx="14630400" cy="8229600"/>
+          </a:xfrm>
+          <a:prstGeom prst="rect">
+            <a:avLst/>
+          </a:prstGeom>
+          <a:solidFill>
+            <a:srgbClr val="000000"/>
+          </a:solidFill>
+          <a:ln>
+            <a:noFill/>
+          </a:ln>
+        </p:spPr>
+        <p:style>
+          <a:lnRef idx="1">
+            <a:schemeClr val="accent1"/>
+          </a:lnRef>
+          <a:fillRef idx="3">
+            <a:schemeClr val="accent1"/>
+          </a:fillRef>
+          <a:effectRef idx="2">
+            <a:schemeClr val="accent1"/>
+          </a:effectRef>
+          <a:fontRef idx="minor">
+            <a:schemeClr val="lt1"/>
+          </a:fontRef>
+        </p:style>
+        <p:txBody>
+          <a:bodyPr rtlCol="0" anchor="ctr"/>
+          <a:lstStyle/>
+          <a:p>
+            <a:pPr algn="ctr"/>
+          </a:p>
+        </p:txBody>
+      </p:sp>
+      <p:sp>
+        <p:nvSpPr>
+          <p:cNvPr id="3" name="Oval 2"/>
+          <p:cNvSpPr/>
+          <p:nvPr/>
+        </p:nvSpPr>
+        <p:spPr>
+          <a:xfrm>
+            <a:off x="8229600" y="1828800"/>
+            <a:ext cx="6400800" cy="6400800"/>
+          </a:xfrm>
+          <a:prstGeom prst="ellipse">
+            <a:avLst/>
+          </a:prstGeom>
+          <a:solidFill>
+            <a:srgbClr val="1E1E1E"/>
+          </a:solidFill>
+          <a:ln>
+            <a:noFill/>
+          </a:ln>
+        </p:spPr>
+        <p:style>
+          <a:lnRef idx="1">
+            <a:schemeClr val="accent1"/>
+          </a:lnRef>
+          <a:fillRef idx="3">
+            <a:schemeClr val="accent1"/>
+          </a:fillRef>
+          <a:effectRef idx="2">
+            <a:schemeClr val="accent1"/>
+          </a:effectRef>
+          <a:fontRef idx="minor">
+            <a:schemeClr val="lt1"/>
+          </a:fontRef>
+        </p:style>
+        <p:txBody>
+          <a:bodyPr rtlCol="0" anchor="ctr"/>
+          <a:lstStyle/>
+          <a:p>
+            <a:pPr algn="ctr"/>
+          </a:p>
+        </p:txBody>
+      </p:sp>
+      <p:sp>
+        <p:nvSpPr>
           <p:cNvPr id="4" name="TextBox 3"/>
           <p:cNvSpPr txBox="1"/>
           <p:nvPr/>
@@ -4368,7 +4792,7 @@
               </a:defRPr>
             </a:pPr>
             <a:r>
-              <a:t>11</a:t>
+              <a:t>12</a:t>
             </a:r>
           </a:p>
         </p:txBody>
@@ -7481,7 +7905,7 @@
             <a:avLst/>
           </a:prstGeom>
           <a:solidFill>
-            <a:srgbClr val="FFDB15"/>
+            <a:srgbClr val="000000"/>
           </a:solidFill>
           <a:ln>
             <a:noFill/>
@@ -7518,29 +7942,33 @@
         <p:spPr>
           <a:xfrm>
             <a:off x="1097280" y="1371600"/>
-            <a:ext cx="9144000" cy="914400"/>
-          </a:xfrm>
-          <a:prstGeom prst="rect">
-            <a:avLst/>
-          </a:prstGeom>
-          <a:noFill/>
-        </p:spPr>
-        <p:txBody>
-          <a:bodyPr wrap="square">
-            <a:spAutoFit/>
-          </a:bodyPr>
-          <a:lstStyle/>
-          <a:p>
-            <a:pPr algn="l">
-              <a:defRPr sz="4800" b="1">
-                <a:solidFill>
-                  <a:srgbClr val="000000"/>
+            <a:ext cx="10972800" cy="1097280"/>
+          </a:xfrm>
+          <a:prstGeom prst="rect">
+            <a:avLst/>
+          </a:prstGeom>
+          <a:noFill/>
+        </p:spPr>
+        <p:txBody>
+          <a:bodyPr wrap="square">
+            <a:spAutoFit/>
+          </a:bodyPr>
+          <a:lstStyle/>
+          <a:p>
+            <a:pPr algn="l">
+              <a:defRPr sz="5200" b="1">
+                <a:solidFill>
+                  <a:srgbClr val="FFFFFF"/>
                 </a:solidFill>
                 <a:latin typeface="Arial"/>
               </a:defRPr>
             </a:pPr>
             <a:r>
-              <a:t>Why we win</a:t>
+              <a:t>Memory outlives</a:t>
+            </a:r>
+            <a:br/>
+            <a:r>
+              <a:t>your model choice</a:t>
             </a:r>
           </a:p>
         </p:txBody>
@@ -7553,8 +7981,8 @@
         </p:nvSpPr>
         <p:spPr>
           <a:xfrm>
-            <a:off x="1097280" y="2286000"/>
-            <a:ext cx="10972800" cy="548640"/>
+            <a:off x="1097280" y="3200400"/>
+            <a:ext cx="7315200" cy="548640"/>
           </a:xfrm>
           <a:prstGeom prst="rect">
             <a:avLst/>
@@ -7570,13 +7998,13 @@
             <a:pPr algn="l">
               <a:defRPr sz="2000" b="0">
                 <a:solidFill>
-                  <a:srgbClr val="1E1E1E"/>
+                  <a:srgbClr val="646464"/>
                 </a:solidFill>
                 <a:latin typeface="Arial"/>
               </a:defRPr>
             </a:pPr>
             <a:r>
-              <a:t>Cognee raised $7.5M validating the category. We're simpler, faster, privacy-first.</a:t>
+              <a:t>One memory layer. Every surface. Any model.</a:t>
             </a:r>
           </a:p>
         </p:txBody>
@@ -7589,8 +8017,8 @@
         </p:nvSpPr>
         <p:spPr>
           <a:xfrm>
-            <a:off x="1097280" y="3200400"/>
-            <a:ext cx="12344400" cy="3840480"/>
+            <a:off x="1097280" y="3931920"/>
+            <a:ext cx="4114800" cy="2926080"/>
           </a:xfrm>
           <a:prstGeom prst="roundRect">
             <a:avLst>
@@ -7598,10 +8026,12 @@
             </a:avLst>
           </a:prstGeom>
           <a:solidFill>
-            <a:srgbClr val="000000"/>
+            <a:srgbClr val="1E1E1E"/>
           </a:solidFill>
-          <a:ln>
-            <a:noFill/>
+          <a:ln w="25400">
+            <a:solidFill>
+              <a:srgbClr val="22D3EE"/>
+            </a:solidFill>
           </a:ln>
         </p:spPr>
         <p:style>
@@ -7634,315 +8064,388 @@
         </p:nvSpPr>
         <p:spPr>
           <a:xfrm>
-            <a:off x="1371600" y="3383280"/>
-            <a:ext cx="3200400" cy="365760"/>
-          </a:xfrm>
-          <a:prstGeom prst="rect">
-            <a:avLst/>
-          </a:prstGeom>
-          <a:noFill/>
-        </p:spPr>
-        <p:txBody>
-          <a:bodyPr wrap="square">
-            <a:spAutoFit/>
-          </a:bodyPr>
-          <a:lstStyle/>
-          <a:p>
-            <a:pPr algn="l">
-              <a:defRPr sz="1400" b="0">
+            <a:off x="1371600" y="4114800"/>
+            <a:ext cx="3657600" cy="457200"/>
+          </a:xfrm>
+          <a:prstGeom prst="rect">
+            <a:avLst/>
+          </a:prstGeom>
+          <a:noFill/>
+        </p:spPr>
+        <p:txBody>
+          <a:bodyPr wrap="square">
+            <a:spAutoFit/>
+          </a:bodyPr>
+          <a:lstStyle/>
+          <a:p>
+            <a:pPr algn="l">
+              <a:defRPr sz="1800" b="1">
+                <a:solidFill>
+                  <a:srgbClr val="22D3EE"/>
+                </a:solidFill>
+                <a:latin typeface="Arial"/>
+              </a:defRPr>
+            </a:pPr>
+            <a:r>
+              <a:t>Model Agnostic</a:t>
+            </a:r>
+          </a:p>
+        </p:txBody>
+      </p:sp>
+      <p:sp>
+        <p:nvSpPr>
+          <p:cNvPr id="7" name="TextBox 6"/>
+          <p:cNvSpPr txBox="1"/>
+          <p:nvPr/>
+        </p:nvSpPr>
+        <p:spPr>
+          <a:xfrm>
+            <a:off x="1371600" y="4663440"/>
+            <a:ext cx="3657600" cy="2011680"/>
+          </a:xfrm>
+          <a:prstGeom prst="rect">
+            <a:avLst/>
+          </a:prstGeom>
+          <a:noFill/>
+        </p:spPr>
+        <p:txBody>
+          <a:bodyPr wrap="square">
+            <a:spAutoFit/>
+          </a:bodyPr>
+          <a:lstStyle/>
+          <a:p>
+            <a:pPr algn="l">
+              <a:defRPr sz="1300" b="0">
+                <a:solidFill>
+                  <a:srgbClr val="FFFFFF"/>
+                </a:solidFill>
+                <a:latin typeface="Arial"/>
+              </a:defRPr>
+            </a:pPr>
+            <a:r>
+              <a:t>✓ Claude → GPT → Gemini</a:t>
+            </a:r>
+            <a:br/>
+            <a:r>
+              <a:t>✓ Switch models, keep memories</a:t>
+            </a:r>
+            <a:br/>
+            <a:r>
+              <a:t>✓ Not locked to OpenAI</a:t>
+            </a:r>
+            <a:br/>
+            <a:r>
+              <a:t>✓ Works with local models</a:t>
+            </a:r>
+            <a:br/>
+            <a:r>
+              <a:t>✓ Future-proof infrastructure</a:t>
+            </a:r>
+          </a:p>
+        </p:txBody>
+      </p:sp>
+      <p:sp>
+        <p:nvSpPr>
+          <p:cNvPr id="8" name="Rounded Rectangle 7"/>
+          <p:cNvSpPr/>
+          <p:nvPr/>
+        </p:nvSpPr>
+        <p:spPr>
+          <a:xfrm>
+            <a:off x="5486400" y="3931920"/>
+            <a:ext cx="4114800" cy="2926080"/>
+          </a:xfrm>
+          <a:prstGeom prst="roundRect">
+            <a:avLst>
+              <a:gd name="adj" fmla="val 5000"/>
+            </a:avLst>
+          </a:prstGeom>
+          <a:solidFill>
+            <a:srgbClr val="1E1E1E"/>
+          </a:solidFill>
+          <a:ln w="25400">
+            <a:solidFill>
+              <a:srgbClr val="22D3EE"/>
+            </a:solidFill>
+          </a:ln>
+        </p:spPr>
+        <p:style>
+          <a:lnRef idx="1">
+            <a:schemeClr val="accent1"/>
+          </a:lnRef>
+          <a:fillRef idx="3">
+            <a:schemeClr val="accent1"/>
+          </a:fillRef>
+          <a:effectRef idx="2">
+            <a:schemeClr val="accent1"/>
+          </a:effectRef>
+          <a:fontRef idx="minor">
+            <a:schemeClr val="lt1"/>
+          </a:fontRef>
+        </p:style>
+        <p:txBody>
+          <a:bodyPr rtlCol="0" anchor="ctr"/>
+          <a:lstStyle/>
+          <a:p>
+            <a:pPr algn="ctr"/>
+          </a:p>
+        </p:txBody>
+      </p:sp>
+      <p:sp>
+        <p:nvSpPr>
+          <p:cNvPr id="9" name="TextBox 8"/>
+          <p:cNvSpPr txBox="1"/>
+          <p:nvPr/>
+        </p:nvSpPr>
+        <p:spPr>
+          <a:xfrm>
+            <a:off x="5760720" y="4114800"/>
+            <a:ext cx="3657600" cy="457200"/>
+          </a:xfrm>
+          <a:prstGeom prst="rect">
+            <a:avLst/>
+          </a:prstGeom>
+          <a:noFill/>
+        </p:spPr>
+        <p:txBody>
+          <a:bodyPr wrap="square">
+            <a:spAutoFit/>
+          </a:bodyPr>
+          <a:lstStyle/>
+          <a:p>
+            <a:pPr algn="l">
+              <a:defRPr sz="1800" b="1">
+                <a:solidFill>
+                  <a:srgbClr val="22D3EE"/>
+                </a:solidFill>
+                <a:latin typeface="Arial"/>
+              </a:defRPr>
+            </a:pPr>
+            <a:r>
+              <a:t>Cross-Platform</a:t>
+            </a:r>
+          </a:p>
+        </p:txBody>
+      </p:sp>
+      <p:sp>
+        <p:nvSpPr>
+          <p:cNvPr id="10" name="TextBox 9"/>
+          <p:cNvSpPr txBox="1"/>
+          <p:nvPr/>
+        </p:nvSpPr>
+        <p:spPr>
+          <a:xfrm>
+            <a:off x="5760720" y="4663440"/>
+            <a:ext cx="3657600" cy="2011680"/>
+          </a:xfrm>
+          <a:prstGeom prst="rect">
+            <a:avLst/>
+          </a:prstGeom>
+          <a:noFill/>
+        </p:spPr>
+        <p:txBody>
+          <a:bodyPr wrap="square">
+            <a:spAutoFit/>
+          </a:bodyPr>
+          <a:lstStyle/>
+          <a:p>
+            <a:pPr algn="l">
+              <a:defRPr sz="1300" b="0">
+                <a:solidFill>
+                  <a:srgbClr val="FFFFFF"/>
+                </a:solidFill>
+                <a:latin typeface="Arial"/>
+              </a:defRPr>
+            </a:pPr>
+            <a:r>
+              <a:t>✓ Telegram, Discord, Slack</a:t>
+            </a:r>
+            <a:br/>
+            <a:r>
+              <a:t>✓ Web, mobile, CLI</a:t>
+            </a:r>
+            <a:br/>
+            <a:r>
+              <a:t>✓ Same memories everywhere</a:t>
+            </a:r>
+            <a:br/>
+            <a:r>
+              <a:t>✓ Any chat surface</a:t>
+            </a:r>
+            <a:br/>
+            <a:r>
+              <a:t>✓ One API, all channels</a:t>
+            </a:r>
+          </a:p>
+        </p:txBody>
+      </p:sp>
+      <p:sp>
+        <p:nvSpPr>
+          <p:cNvPr id="11" name="Rounded Rectangle 10"/>
+          <p:cNvSpPr/>
+          <p:nvPr/>
+        </p:nvSpPr>
+        <p:spPr>
+          <a:xfrm>
+            <a:off x="9875520" y="3931920"/>
+            <a:ext cx="4114800" cy="2926080"/>
+          </a:xfrm>
+          <a:prstGeom prst="roundRect">
+            <a:avLst>
+              <a:gd name="adj" fmla="val 5000"/>
+            </a:avLst>
+          </a:prstGeom>
+          <a:solidFill>
+            <a:srgbClr val="1E1E1E"/>
+          </a:solidFill>
+          <a:ln w="25400">
+            <a:solidFill>
+              <a:srgbClr val="22D3EE"/>
+            </a:solidFill>
+          </a:ln>
+        </p:spPr>
+        <p:style>
+          <a:lnRef idx="1">
+            <a:schemeClr val="accent1"/>
+          </a:lnRef>
+          <a:fillRef idx="3">
+            <a:schemeClr val="accent1"/>
+          </a:fillRef>
+          <a:effectRef idx="2">
+            <a:schemeClr val="accent1"/>
+          </a:effectRef>
+          <a:fontRef idx="minor">
+            <a:schemeClr val="lt1"/>
+          </a:fontRef>
+        </p:style>
+        <p:txBody>
+          <a:bodyPr rtlCol="0" anchor="ctr"/>
+          <a:lstStyle/>
+          <a:p>
+            <a:pPr algn="ctr"/>
+          </a:p>
+        </p:txBody>
+      </p:sp>
+      <p:sp>
+        <p:nvSpPr>
+          <p:cNvPr id="12" name="TextBox 11"/>
+          <p:cNvSpPr txBox="1"/>
+          <p:nvPr/>
+        </p:nvSpPr>
+        <p:spPr>
+          <a:xfrm>
+            <a:off x="10149840" y="4114800"/>
+            <a:ext cx="3657600" cy="457200"/>
+          </a:xfrm>
+          <a:prstGeom prst="rect">
+            <a:avLst/>
+          </a:prstGeom>
+          <a:noFill/>
+        </p:spPr>
+        <p:txBody>
+          <a:bodyPr wrap="square">
+            <a:spAutoFit/>
+          </a:bodyPr>
+          <a:lstStyle/>
+          <a:p>
+            <a:pPr algn="l">
+              <a:defRPr sz="1800" b="1">
+                <a:solidFill>
+                  <a:srgbClr val="22D3EE"/>
+                </a:solidFill>
+                <a:latin typeface="Arial"/>
+              </a:defRPr>
+            </a:pPr>
+            <a:r>
+              <a:t>Cross-Device</a:t>
+            </a:r>
+          </a:p>
+        </p:txBody>
+      </p:sp>
+      <p:sp>
+        <p:nvSpPr>
+          <p:cNvPr id="13" name="TextBox 12"/>
+          <p:cNvSpPr txBox="1"/>
+          <p:nvPr/>
+        </p:nvSpPr>
+        <p:spPr>
+          <a:xfrm>
+            <a:off x="10149840" y="4663440"/>
+            <a:ext cx="3657600" cy="2011680"/>
+          </a:xfrm>
+          <a:prstGeom prst="rect">
+            <a:avLst/>
+          </a:prstGeom>
+          <a:noFill/>
+        </p:spPr>
+        <p:txBody>
+          <a:bodyPr wrap="square">
+            <a:spAutoFit/>
+          </a:bodyPr>
+          <a:lstStyle/>
+          <a:p>
+            <a:pPr algn="l">
+              <a:defRPr sz="1300" b="0">
+                <a:solidFill>
+                  <a:srgbClr val="FFFFFF"/>
+                </a:solidFill>
+                <a:latin typeface="Arial"/>
+              </a:defRPr>
+            </a:pPr>
+            <a:r>
+              <a:t>✓ Cloud-native storage</a:t>
+            </a:r>
+            <a:br/>
+            <a:r>
+              <a:t>✓ Survives restarts</a:t>
+            </a:r>
+            <a:br/>
+            <a:r>
+              <a:t>✓ Works from any device</a:t>
+            </a:r>
+            <a:br/>
+            <a:r>
+              <a:t>✓ Encrypted in transit &amp; rest</a:t>
+            </a:r>
+            <a:br/>
+            <a:r>
+              <a:t>✓ No local dependencies</a:t>
+            </a:r>
+          </a:p>
+        </p:txBody>
+      </p:sp>
+      <p:sp>
+        <p:nvSpPr>
+          <p:cNvPr id="14" name="TextBox 13"/>
+          <p:cNvSpPr txBox="1"/>
+          <p:nvPr/>
+        </p:nvSpPr>
+        <p:spPr>
+          <a:xfrm>
+            <a:off x="1097280" y="7315200"/>
+            <a:ext cx="9144000" cy="457200"/>
+          </a:xfrm>
+          <a:prstGeom prst="rect">
+            <a:avLst/>
+          </a:prstGeom>
+          <a:noFill/>
+        </p:spPr>
+        <p:txBody>
+          <a:bodyPr wrap="square">
+            <a:spAutoFit/>
+          </a:bodyPr>
+          <a:lstStyle/>
+          <a:p>
+            <a:pPr algn="l">
+              <a:defRPr sz="1600" b="0">
                 <a:solidFill>
                   <a:srgbClr val="646464"/>
                 </a:solidFill>
                 <a:latin typeface="Arial"/>
               </a:defRPr>
             </a:pPr>
-          </a:p>
-        </p:txBody>
-      </p:sp>
-      <p:sp>
-        <p:nvSpPr>
-          <p:cNvPr id="7" name="TextBox 6"/>
-          <p:cNvSpPr txBox="1"/>
-          <p:nvPr/>
-        </p:nvSpPr>
-        <p:spPr>
-          <a:xfrm>
-            <a:off x="4754880" y="3383280"/>
-            <a:ext cx="3200400" cy="365760"/>
-          </a:xfrm>
-          <a:prstGeom prst="rect">
-            <a:avLst/>
-          </a:prstGeom>
-          <a:noFill/>
-        </p:spPr>
-        <p:txBody>
-          <a:bodyPr wrap="square">
-            <a:spAutoFit/>
-          </a:bodyPr>
-          <a:lstStyle/>
-          <a:p>
-            <a:pPr algn="l">
-              <a:defRPr sz="1400" b="1">
-                <a:solidFill>
-                  <a:srgbClr val="646464"/>
-                </a:solidFill>
-                <a:latin typeface="Arial"/>
-              </a:defRPr>
-            </a:pPr>
-            <a:r>
-              <a:t>Cognee</a:t>
-            </a:r>
-          </a:p>
-        </p:txBody>
-      </p:sp>
-      <p:sp>
-        <p:nvSpPr>
-          <p:cNvPr id="8" name="TextBox 7"/>
-          <p:cNvSpPr txBox="1"/>
-          <p:nvPr/>
-        </p:nvSpPr>
-        <p:spPr>
-          <a:xfrm>
-            <a:off x="8686800" y="3383280"/>
-            <a:ext cx="3200400" cy="365760"/>
-          </a:xfrm>
-          <a:prstGeom prst="rect">
-            <a:avLst/>
-          </a:prstGeom>
-          <a:noFill/>
-        </p:spPr>
-        <p:txBody>
-          <a:bodyPr wrap="square">
-            <a:spAutoFit/>
-          </a:bodyPr>
-          <a:lstStyle/>
-          <a:p>
-            <a:pPr algn="l">
-              <a:defRPr sz="1400" b="1">
-                <a:solidFill>
-                  <a:srgbClr val="646464"/>
-                </a:solidFill>
-                <a:latin typeface="Arial"/>
-              </a:defRPr>
-            </a:pPr>
-            <a:r>
-              <a:t>Mem0</a:t>
-            </a:r>
-          </a:p>
-        </p:txBody>
-      </p:sp>
-      <p:sp>
-        <p:nvSpPr>
-          <p:cNvPr id="9" name="TextBox 8"/>
-          <p:cNvSpPr txBox="1"/>
-          <p:nvPr/>
-        </p:nvSpPr>
-        <p:spPr>
-          <a:xfrm>
-            <a:off x="11430000" y="3383280"/>
-            <a:ext cx="1828800" cy="365760"/>
-          </a:xfrm>
-          <a:prstGeom prst="rect">
-            <a:avLst/>
-          </a:prstGeom>
-          <a:noFill/>
-        </p:spPr>
-        <p:txBody>
-          <a:bodyPr wrap="square">
-            <a:spAutoFit/>
-          </a:bodyPr>
-          <a:lstStyle/>
-          <a:p>
-            <a:pPr algn="l">
-              <a:defRPr sz="1400" b="1">
-                <a:solidFill>
-                  <a:srgbClr val="FFDB15"/>
-                </a:solidFill>
-                <a:latin typeface="Arial"/>
-              </a:defRPr>
-            </a:pPr>
-            <a:r>
-              <a:t>Engrm</a:t>
-            </a:r>
-          </a:p>
-        </p:txBody>
-      </p:sp>
-      <p:sp>
-        <p:nvSpPr>
-          <p:cNvPr id="10" name="TextBox 9"/>
-          <p:cNvSpPr txBox="1"/>
-          <p:nvPr/>
-        </p:nvSpPr>
-        <p:spPr>
-          <a:xfrm>
-            <a:off x="1371600" y="3840480"/>
-            <a:ext cx="3200400" cy="457200"/>
-          </a:xfrm>
-          <a:prstGeom prst="rect">
-            <a:avLst/>
-          </a:prstGeom>
-          <a:noFill/>
-        </p:spPr>
-        <p:txBody>
-          <a:bodyPr wrap="square">
-            <a:spAutoFit/>
-          </a:bodyPr>
-          <a:lstStyle/>
-          <a:p>
-            <a:pPr algn="l">
-              <a:defRPr sz="1200" b="0">
-                <a:solidFill>
-                  <a:srgbClr val="646464"/>
-                </a:solidFill>
-                <a:latin typeface="Arial"/>
-              </a:defRPr>
-            </a:pPr>
-            <a:r>
-              <a:t>Setup</a:t>
-            </a:r>
-          </a:p>
-        </p:txBody>
-      </p:sp>
-      <p:sp>
-        <p:nvSpPr>
-          <p:cNvPr id="11" name="TextBox 10"/>
-          <p:cNvSpPr txBox="1"/>
-          <p:nvPr/>
-        </p:nvSpPr>
-        <p:spPr>
-          <a:xfrm>
-            <a:off x="4754880" y="3840480"/>
-            <a:ext cx="3200400" cy="457200"/>
-          </a:xfrm>
-          <a:prstGeom prst="rect">
-            <a:avLst/>
-          </a:prstGeom>
-          <a:noFill/>
-        </p:spPr>
-        <p:txBody>
-          <a:bodyPr wrap="square">
-            <a:spAutoFit/>
-          </a:bodyPr>
-          <a:lstStyle/>
-          <a:p>
-            <a:pPr algn="l">
-              <a:defRPr sz="1200" b="0">
-                <a:solidFill>
-                  <a:srgbClr val="FFFFFF"/>
-                </a:solidFill>
-                <a:latin typeface="Arial"/>
-              </a:defRPr>
-            </a:pPr>
-            <a:r>
-              <a:t>Days</a:t>
-            </a:r>
-          </a:p>
-        </p:txBody>
-      </p:sp>
-      <p:sp>
-        <p:nvSpPr>
-          <p:cNvPr id="12" name="TextBox 11"/>
-          <p:cNvSpPr txBox="1"/>
-          <p:nvPr/>
-        </p:nvSpPr>
-        <p:spPr>
-          <a:xfrm>
-            <a:off x="8686800" y="3840480"/>
-            <a:ext cx="2286000" cy="457200"/>
-          </a:xfrm>
-          <a:prstGeom prst="rect">
-            <a:avLst/>
-          </a:prstGeom>
-          <a:noFill/>
-        </p:spPr>
-        <p:txBody>
-          <a:bodyPr wrap="square">
-            <a:spAutoFit/>
-          </a:bodyPr>
-          <a:lstStyle/>
-          <a:p>
-            <a:pPr algn="l">
-              <a:defRPr sz="1200" b="0">
-                <a:solidFill>
-                  <a:srgbClr val="FFFFFF"/>
-                </a:solidFill>
-                <a:latin typeface="Arial"/>
-              </a:defRPr>
-            </a:pPr>
-            <a:r>
-              <a:t>Minutes</a:t>
-            </a:r>
-          </a:p>
-        </p:txBody>
-      </p:sp>
-      <p:sp>
-        <p:nvSpPr>
-          <p:cNvPr id="13" name="TextBox 12"/>
-          <p:cNvSpPr txBox="1"/>
-          <p:nvPr/>
-        </p:nvSpPr>
-        <p:spPr>
-          <a:xfrm>
-            <a:off x="11430000" y="3840480"/>
-            <a:ext cx="1828800" cy="457200"/>
-          </a:xfrm>
-          <a:prstGeom prst="rect">
-            <a:avLst/>
-          </a:prstGeom>
-          <a:noFill/>
-        </p:spPr>
-        <p:txBody>
-          <a:bodyPr wrap="square">
-            <a:spAutoFit/>
-          </a:bodyPr>
-          <a:lstStyle/>
-          <a:p>
-            <a:pPr algn="l">
-              <a:defRPr sz="1200" b="0">
-                <a:solidFill>
-                  <a:srgbClr val="FFDB15"/>
-                </a:solidFill>
-                <a:latin typeface="Arial"/>
-              </a:defRPr>
-            </a:pPr>
-            <a:r>
-              <a:t>Minutes</a:t>
-            </a:r>
-          </a:p>
-        </p:txBody>
-      </p:sp>
-      <p:sp>
-        <p:nvSpPr>
-          <p:cNvPr id="14" name="TextBox 13"/>
-          <p:cNvSpPr txBox="1"/>
-          <p:nvPr/>
-        </p:nvSpPr>
-        <p:spPr>
-          <a:xfrm>
-            <a:off x="1371600" y="4343400"/>
-            <a:ext cx="3200400" cy="457200"/>
-          </a:xfrm>
-          <a:prstGeom prst="rect">
-            <a:avLst/>
-          </a:prstGeom>
-          <a:noFill/>
-        </p:spPr>
-        <p:txBody>
-          <a:bodyPr wrap="square">
-            <a:spAutoFit/>
-          </a:bodyPr>
-          <a:lstStyle/>
-          <a:p>
-            <a:pPr algn="l">
-              <a:defRPr sz="1200" b="0">
-                <a:solidFill>
-                  <a:srgbClr val="646464"/>
-                </a:solidFill>
-                <a:latin typeface="Arial"/>
-              </a:defRPr>
-            </a:pPr>
-            <a:r>
-              <a:t>Integration</a:t>
+            <a:r>
+              <a:t>ChatGPT memory is locked to OpenAI. Engrm memory is yours.</a:t>
             </a:r>
           </a:p>
         </p:txBody>
@@ -7950,690 +8453,6 @@
       <p:sp>
         <p:nvSpPr>
           <p:cNvPr id="15" name="TextBox 14"/>
-          <p:cNvSpPr txBox="1"/>
-          <p:nvPr/>
-        </p:nvSpPr>
-        <p:spPr>
-          <a:xfrm>
-            <a:off x="4754880" y="4343400"/>
-            <a:ext cx="3200400" cy="457200"/>
-          </a:xfrm>
-          <a:prstGeom prst="rect">
-            <a:avLst/>
-          </a:prstGeom>
-          <a:noFill/>
-        </p:spPr>
-        <p:txBody>
-          <a:bodyPr wrap="square">
-            <a:spAutoFit/>
-          </a:bodyPr>
-          <a:lstStyle/>
-          <a:p>
-            <a:pPr algn="l">
-              <a:defRPr sz="1200" b="0">
-                <a:solidFill>
-                  <a:srgbClr val="FFFFFF"/>
-                </a:solidFill>
-                <a:latin typeface="Arial"/>
-              </a:defRPr>
-            </a:pPr>
-            <a:r>
-              <a:t>ECL pipeline</a:t>
-            </a:r>
-          </a:p>
-        </p:txBody>
-      </p:sp>
-      <p:sp>
-        <p:nvSpPr>
-          <p:cNvPr id="16" name="TextBox 15"/>
-          <p:cNvSpPr txBox="1"/>
-          <p:nvPr/>
-        </p:nvSpPr>
-        <p:spPr>
-          <a:xfrm>
-            <a:off x="8686800" y="4343400"/>
-            <a:ext cx="2286000" cy="457200"/>
-          </a:xfrm>
-          <a:prstGeom prst="rect">
-            <a:avLst/>
-          </a:prstGeom>
-          <a:noFill/>
-        </p:spPr>
-        <p:txBody>
-          <a:bodyPr wrap="square">
-            <a:spAutoFit/>
-          </a:bodyPr>
-          <a:lstStyle/>
-          <a:p>
-            <a:pPr algn="l">
-              <a:defRPr sz="1200" b="0">
-                <a:solidFill>
-                  <a:srgbClr val="FFFFFF"/>
-                </a:solidFill>
-                <a:latin typeface="Arial"/>
-              </a:defRPr>
-            </a:pPr>
-            <a:r>
-              <a:t>Simple API</a:t>
-            </a:r>
-          </a:p>
-        </p:txBody>
-      </p:sp>
-      <p:sp>
-        <p:nvSpPr>
-          <p:cNvPr id="17" name="TextBox 16"/>
-          <p:cNvSpPr txBox="1"/>
-          <p:nvPr/>
-        </p:nvSpPr>
-        <p:spPr>
-          <a:xfrm>
-            <a:off x="11430000" y="4343400"/>
-            <a:ext cx="1828800" cy="457200"/>
-          </a:xfrm>
-          <a:prstGeom prst="rect">
-            <a:avLst/>
-          </a:prstGeom>
-          <a:noFill/>
-        </p:spPr>
-        <p:txBody>
-          <a:bodyPr wrap="square">
-            <a:spAutoFit/>
-          </a:bodyPr>
-          <a:lstStyle/>
-          <a:p>
-            <a:pPr algn="l">
-              <a:defRPr sz="1200" b="0">
-                <a:solidFill>
-                  <a:srgbClr val="FFDB15"/>
-                </a:solidFill>
-                <a:latin typeface="Arial"/>
-              </a:defRPr>
-            </a:pPr>
-            <a:r>
-              <a:t>2 endpoints</a:t>
-            </a:r>
-          </a:p>
-        </p:txBody>
-      </p:sp>
-      <p:sp>
-        <p:nvSpPr>
-          <p:cNvPr id="18" name="TextBox 17"/>
-          <p:cNvSpPr txBox="1"/>
-          <p:nvPr/>
-        </p:nvSpPr>
-        <p:spPr>
-          <a:xfrm>
-            <a:off x="1371600" y="4846320"/>
-            <a:ext cx="3200400" cy="457200"/>
-          </a:xfrm>
-          <a:prstGeom prst="rect">
-            <a:avLst/>
-          </a:prstGeom>
-          <a:noFill/>
-        </p:spPr>
-        <p:txBody>
-          <a:bodyPr wrap="square">
-            <a:spAutoFit/>
-          </a:bodyPr>
-          <a:lstStyle/>
-          <a:p>
-            <a:pPr algn="l">
-              <a:defRPr sz="1200" b="0">
-                <a:solidFill>
-                  <a:srgbClr val="646464"/>
-                </a:solidFill>
-                <a:latin typeface="Arial"/>
-              </a:defRPr>
-            </a:pPr>
-            <a:r>
-              <a:t>Infrastructure</a:t>
-            </a:r>
-          </a:p>
-        </p:txBody>
-      </p:sp>
-      <p:sp>
-        <p:nvSpPr>
-          <p:cNvPr id="19" name="TextBox 18"/>
-          <p:cNvSpPr txBox="1"/>
-          <p:nvPr/>
-        </p:nvSpPr>
-        <p:spPr>
-          <a:xfrm>
-            <a:off x="4754880" y="4846320"/>
-            <a:ext cx="3200400" cy="457200"/>
-          </a:xfrm>
-          <a:prstGeom prst="rect">
-            <a:avLst/>
-          </a:prstGeom>
-          <a:noFill/>
-        </p:spPr>
-        <p:txBody>
-          <a:bodyPr wrap="square">
-            <a:spAutoFit/>
-          </a:bodyPr>
-          <a:lstStyle/>
-          <a:p>
-            <a:pPr algn="l">
-              <a:defRPr sz="1200" b="0">
-                <a:solidFill>
-                  <a:srgbClr val="FFFFFF"/>
-                </a:solidFill>
-                <a:latin typeface="Arial"/>
-              </a:defRPr>
-            </a:pPr>
-            <a:r>
-              <a:t>Graph + Vector + SQL</a:t>
-            </a:r>
-          </a:p>
-        </p:txBody>
-      </p:sp>
-      <p:sp>
-        <p:nvSpPr>
-          <p:cNvPr id="20" name="TextBox 19"/>
-          <p:cNvSpPr txBox="1"/>
-          <p:nvPr/>
-        </p:nvSpPr>
-        <p:spPr>
-          <a:xfrm>
-            <a:off x="8686800" y="4846320"/>
-            <a:ext cx="2286000" cy="457200"/>
-          </a:xfrm>
-          <a:prstGeom prst="rect">
-            <a:avLst/>
-          </a:prstGeom>
-          <a:noFill/>
-        </p:spPr>
-        <p:txBody>
-          <a:bodyPr wrap="square">
-            <a:spAutoFit/>
-          </a:bodyPr>
-          <a:lstStyle/>
-          <a:p>
-            <a:pPr algn="l">
-              <a:defRPr sz="1200" b="0">
-                <a:solidFill>
-                  <a:srgbClr val="FFFFFF"/>
-                </a:solidFill>
-                <a:latin typeface="Arial"/>
-              </a:defRPr>
-            </a:pPr>
-            <a:r>
-              <a:t>Hosted</a:t>
-            </a:r>
-          </a:p>
-        </p:txBody>
-      </p:sp>
-      <p:sp>
-        <p:nvSpPr>
-          <p:cNvPr id="21" name="TextBox 20"/>
-          <p:cNvSpPr txBox="1"/>
-          <p:nvPr/>
-        </p:nvSpPr>
-        <p:spPr>
-          <a:xfrm>
-            <a:off x="11430000" y="4846320"/>
-            <a:ext cx="1828800" cy="457200"/>
-          </a:xfrm>
-          <a:prstGeom prst="rect">
-            <a:avLst/>
-          </a:prstGeom>
-          <a:noFill/>
-        </p:spPr>
-        <p:txBody>
-          <a:bodyPr wrap="square">
-            <a:spAutoFit/>
-          </a:bodyPr>
-          <a:lstStyle/>
-          <a:p>
-            <a:pPr algn="l">
-              <a:defRPr sz="1200" b="0">
-                <a:solidFill>
-                  <a:srgbClr val="FFDB15"/>
-                </a:solidFill>
-                <a:latin typeface="Arial"/>
-              </a:defRPr>
-            </a:pPr>
-            <a:r>
-              <a:t>Managed</a:t>
-            </a:r>
-          </a:p>
-        </p:txBody>
-      </p:sp>
-      <p:sp>
-        <p:nvSpPr>
-          <p:cNvPr id="22" name="TextBox 21"/>
-          <p:cNvSpPr txBox="1"/>
-          <p:nvPr/>
-        </p:nvSpPr>
-        <p:spPr>
-          <a:xfrm>
-            <a:off x="1371600" y="5349240"/>
-            <a:ext cx="3200400" cy="457200"/>
-          </a:xfrm>
-          <a:prstGeom prst="rect">
-            <a:avLst/>
-          </a:prstGeom>
-          <a:noFill/>
-        </p:spPr>
-        <p:txBody>
-          <a:bodyPr wrap="square">
-            <a:spAutoFit/>
-          </a:bodyPr>
-          <a:lstStyle/>
-          <a:p>
-            <a:pPr algn="l">
-              <a:defRPr sz="1200" b="0">
-                <a:solidFill>
-                  <a:srgbClr val="646464"/>
-                </a:solidFill>
-                <a:latin typeface="Arial"/>
-              </a:defRPr>
-            </a:pPr>
-            <a:r>
-              <a:t>Encryption</a:t>
-            </a:r>
-          </a:p>
-        </p:txBody>
-      </p:sp>
-      <p:sp>
-        <p:nvSpPr>
-          <p:cNvPr id="23" name="TextBox 22"/>
-          <p:cNvSpPr txBox="1"/>
-          <p:nvPr/>
-        </p:nvSpPr>
-        <p:spPr>
-          <a:xfrm>
-            <a:off x="4754880" y="5349240"/>
-            <a:ext cx="3200400" cy="457200"/>
-          </a:xfrm>
-          <a:prstGeom prst="rect">
-            <a:avLst/>
-          </a:prstGeom>
-          <a:noFill/>
-        </p:spPr>
-        <p:txBody>
-          <a:bodyPr wrap="square">
-            <a:spAutoFit/>
-          </a:bodyPr>
-          <a:lstStyle/>
-          <a:p>
-            <a:pPr algn="l">
-              <a:defRPr sz="1200" b="0">
-                <a:solidFill>
-                  <a:srgbClr val="FFFFFF"/>
-                </a:solidFill>
-                <a:latin typeface="Arial"/>
-              </a:defRPr>
-            </a:pPr>
-            <a:r>
-              <a:t>Enterprise tier</a:t>
-            </a:r>
-          </a:p>
-        </p:txBody>
-      </p:sp>
-      <p:sp>
-        <p:nvSpPr>
-          <p:cNvPr id="24" name="TextBox 23"/>
-          <p:cNvSpPr txBox="1"/>
-          <p:nvPr/>
-        </p:nvSpPr>
-        <p:spPr>
-          <a:xfrm>
-            <a:off x="8686800" y="5349240"/>
-            <a:ext cx="2286000" cy="457200"/>
-          </a:xfrm>
-          <a:prstGeom prst="rect">
-            <a:avLst/>
-          </a:prstGeom>
-          <a:noFill/>
-        </p:spPr>
-        <p:txBody>
-          <a:bodyPr wrap="square">
-            <a:spAutoFit/>
-          </a:bodyPr>
-          <a:lstStyle/>
-          <a:p>
-            <a:pPr algn="l">
-              <a:defRPr sz="1200" b="0">
-                <a:solidFill>
-                  <a:srgbClr val="FFFFFF"/>
-                </a:solidFill>
-                <a:latin typeface="Arial"/>
-              </a:defRPr>
-            </a:pPr>
-            <a:r>
-              <a:t>Optional</a:t>
-            </a:r>
-          </a:p>
-        </p:txBody>
-      </p:sp>
-      <p:sp>
-        <p:nvSpPr>
-          <p:cNvPr id="25" name="TextBox 24"/>
-          <p:cNvSpPr txBox="1"/>
-          <p:nvPr/>
-        </p:nvSpPr>
-        <p:spPr>
-          <a:xfrm>
-            <a:off x="11430000" y="5349240"/>
-            <a:ext cx="1828800" cy="457200"/>
-          </a:xfrm>
-          <a:prstGeom prst="rect">
-            <a:avLst/>
-          </a:prstGeom>
-          <a:noFill/>
-        </p:spPr>
-        <p:txBody>
-          <a:bodyPr wrap="square">
-            <a:spAutoFit/>
-          </a:bodyPr>
-          <a:lstStyle/>
-          <a:p>
-            <a:pPr algn="l">
-              <a:defRPr sz="1200" b="0">
-                <a:solidFill>
-                  <a:srgbClr val="FFDB15"/>
-                </a:solidFill>
-                <a:latin typeface="Arial"/>
-              </a:defRPr>
-            </a:pPr>
-            <a:r>
-              <a:t>Default ✓</a:t>
-            </a:r>
-          </a:p>
-        </p:txBody>
-      </p:sp>
-      <p:sp>
-        <p:nvSpPr>
-          <p:cNvPr id="26" name="TextBox 25"/>
-          <p:cNvSpPr txBox="1"/>
-          <p:nvPr/>
-        </p:nvSpPr>
-        <p:spPr>
-          <a:xfrm>
-            <a:off x="1371600" y="5852160"/>
-            <a:ext cx="3200400" cy="457200"/>
-          </a:xfrm>
-          <a:prstGeom prst="rect">
-            <a:avLst/>
-          </a:prstGeom>
-          <a:noFill/>
-        </p:spPr>
-        <p:txBody>
-          <a:bodyPr wrap="square">
-            <a:spAutoFit/>
-          </a:bodyPr>
-          <a:lstStyle/>
-          <a:p>
-            <a:pPr algn="l">
-              <a:defRPr sz="1200" b="0">
-                <a:solidFill>
-                  <a:srgbClr val="646464"/>
-                </a:solidFill>
-                <a:latin typeface="Arial"/>
-              </a:defRPr>
-            </a:pPr>
-            <a:r>
-              <a:t>Self-improving</a:t>
-            </a:r>
-          </a:p>
-        </p:txBody>
-      </p:sp>
-      <p:sp>
-        <p:nvSpPr>
-          <p:cNvPr id="27" name="TextBox 26"/>
-          <p:cNvSpPr txBox="1"/>
-          <p:nvPr/>
-        </p:nvSpPr>
-        <p:spPr>
-          <a:xfrm>
-            <a:off x="4754880" y="5852160"/>
-            <a:ext cx="3200400" cy="457200"/>
-          </a:xfrm>
-          <a:prstGeom prst="rect">
-            <a:avLst/>
-          </a:prstGeom>
-          <a:noFill/>
-        </p:spPr>
-        <p:txBody>
-          <a:bodyPr wrap="square">
-            <a:spAutoFit/>
-          </a:bodyPr>
-          <a:lstStyle/>
-          <a:p>
-            <a:pPr algn="l">
-              <a:defRPr sz="1200" b="0">
-                <a:solidFill>
-                  <a:srgbClr val="FFFFFF"/>
-                </a:solidFill>
-                <a:latin typeface="Arial"/>
-              </a:defRPr>
-            </a:pPr>
-            <a:r>
-              <a:t>Complex tuning</a:t>
-            </a:r>
-          </a:p>
-        </p:txBody>
-      </p:sp>
-      <p:sp>
-        <p:nvSpPr>
-          <p:cNvPr id="28" name="TextBox 27"/>
-          <p:cNvSpPr txBox="1"/>
-          <p:nvPr/>
-        </p:nvSpPr>
-        <p:spPr>
-          <a:xfrm>
-            <a:off x="8686800" y="5852160"/>
-            <a:ext cx="2286000" cy="457200"/>
-          </a:xfrm>
-          <a:prstGeom prst="rect">
-            <a:avLst/>
-          </a:prstGeom>
-          <a:noFill/>
-        </p:spPr>
-        <p:txBody>
-          <a:bodyPr wrap="square">
-            <a:spAutoFit/>
-          </a:bodyPr>
-          <a:lstStyle/>
-          <a:p>
-            <a:pPr algn="l">
-              <a:defRPr sz="1200" b="0">
-                <a:solidFill>
-                  <a:srgbClr val="FFFFFF"/>
-                </a:solidFill>
-                <a:latin typeface="Arial"/>
-              </a:defRPr>
-            </a:pPr>
-            <a:r>
-              <a:t>Limited</a:t>
-            </a:r>
-          </a:p>
-        </p:txBody>
-      </p:sp>
-      <p:sp>
-        <p:nvSpPr>
-          <p:cNvPr id="29" name="TextBox 28"/>
-          <p:cNvSpPr txBox="1"/>
-          <p:nvPr/>
-        </p:nvSpPr>
-        <p:spPr>
-          <a:xfrm>
-            <a:off x="11430000" y="5852160"/>
-            <a:ext cx="1828800" cy="457200"/>
-          </a:xfrm>
-          <a:prstGeom prst="rect">
-            <a:avLst/>
-          </a:prstGeom>
-          <a:noFill/>
-        </p:spPr>
-        <p:txBody>
-          <a:bodyPr wrap="square">
-            <a:spAutoFit/>
-          </a:bodyPr>
-          <a:lstStyle/>
-          <a:p>
-            <a:pPr algn="l">
-              <a:defRPr sz="1200" b="0">
-                <a:solidFill>
-                  <a:srgbClr val="FFDB15"/>
-                </a:solidFill>
-                <a:latin typeface="Arial"/>
-              </a:defRPr>
-            </a:pPr>
-            <a:r>
-              <a:t>Built-in ✓</a:t>
-            </a:r>
-          </a:p>
-        </p:txBody>
-      </p:sp>
-      <p:sp>
-        <p:nvSpPr>
-          <p:cNvPr id="30" name="TextBox 29"/>
-          <p:cNvSpPr txBox="1"/>
-          <p:nvPr/>
-        </p:nvSpPr>
-        <p:spPr>
-          <a:xfrm>
-            <a:off x="1371600" y="6355080"/>
-            <a:ext cx="3200400" cy="457200"/>
-          </a:xfrm>
-          <a:prstGeom prst="rect">
-            <a:avLst/>
-          </a:prstGeom>
-          <a:noFill/>
-        </p:spPr>
-        <p:txBody>
-          <a:bodyPr wrap="square">
-            <a:spAutoFit/>
-          </a:bodyPr>
-          <a:lstStyle/>
-          <a:p>
-            <a:pPr algn="l">
-              <a:defRPr sz="1200" b="0">
-                <a:solidFill>
-                  <a:srgbClr val="646464"/>
-                </a:solidFill>
-                <a:latin typeface="Arial"/>
-              </a:defRPr>
-            </a:pPr>
-            <a:r>
-              <a:t>Privacy model</a:t>
-            </a:r>
-          </a:p>
-        </p:txBody>
-      </p:sp>
-      <p:sp>
-        <p:nvSpPr>
-          <p:cNvPr id="31" name="TextBox 30"/>
-          <p:cNvSpPr txBox="1"/>
-          <p:nvPr/>
-        </p:nvSpPr>
-        <p:spPr>
-          <a:xfrm>
-            <a:off x="4754880" y="6355080"/>
-            <a:ext cx="3200400" cy="457200"/>
-          </a:xfrm>
-          <a:prstGeom prst="rect">
-            <a:avLst/>
-          </a:prstGeom>
-          <a:noFill/>
-        </p:spPr>
-        <p:txBody>
-          <a:bodyPr wrap="square">
-            <a:spAutoFit/>
-          </a:bodyPr>
-          <a:lstStyle/>
-          <a:p>
-            <a:pPr algn="l">
-              <a:defRPr sz="1200" b="0">
-                <a:solidFill>
-                  <a:srgbClr val="FFFFFF"/>
-                </a:solidFill>
-                <a:latin typeface="Arial"/>
-              </a:defRPr>
-            </a:pPr>
-            <a:r>
-              <a:t>Standard</a:t>
-            </a:r>
-          </a:p>
-        </p:txBody>
-      </p:sp>
-      <p:sp>
-        <p:nvSpPr>
-          <p:cNvPr id="32" name="TextBox 31"/>
-          <p:cNvSpPr txBox="1"/>
-          <p:nvPr/>
-        </p:nvSpPr>
-        <p:spPr>
-          <a:xfrm>
-            <a:off x="8686800" y="6355080"/>
-            <a:ext cx="2286000" cy="457200"/>
-          </a:xfrm>
-          <a:prstGeom prst="rect">
-            <a:avLst/>
-          </a:prstGeom>
-          <a:noFill/>
-        </p:spPr>
-        <p:txBody>
-          <a:bodyPr wrap="square">
-            <a:spAutoFit/>
-          </a:bodyPr>
-          <a:lstStyle/>
-          <a:p>
-            <a:pPr algn="l">
-              <a:defRPr sz="1200" b="0">
-                <a:solidFill>
-                  <a:srgbClr val="FFFFFF"/>
-                </a:solidFill>
-                <a:latin typeface="Arial"/>
-              </a:defRPr>
-            </a:pPr>
-            <a:r>
-              <a:t>Standard</a:t>
-            </a:r>
-          </a:p>
-        </p:txBody>
-      </p:sp>
-      <p:sp>
-        <p:nvSpPr>
-          <p:cNvPr id="33" name="TextBox 32"/>
-          <p:cNvSpPr txBox="1"/>
-          <p:nvPr/>
-        </p:nvSpPr>
-        <p:spPr>
-          <a:xfrm>
-            <a:off x="11430000" y="6355080"/>
-            <a:ext cx="1828800" cy="457200"/>
-          </a:xfrm>
-          <a:prstGeom prst="rect">
-            <a:avLst/>
-          </a:prstGeom>
-          <a:noFill/>
-        </p:spPr>
-        <p:txBody>
-          <a:bodyPr wrap="square">
-            <a:spAutoFit/>
-          </a:bodyPr>
-          <a:lstStyle/>
-          <a:p>
-            <a:pPr algn="l">
-              <a:defRPr sz="1200" b="0">
-                <a:solidFill>
-                  <a:srgbClr val="FFDB15"/>
-                </a:solidFill>
-                <a:latin typeface="Arial"/>
-              </a:defRPr>
-            </a:pPr>
-            <a:r>
-              <a:t>User-only ✓</a:t>
-            </a:r>
-          </a:p>
-        </p:txBody>
-      </p:sp>
-      <p:sp>
-        <p:nvSpPr>
-          <p:cNvPr id="34" name="TextBox 33"/>
           <p:cNvSpPr txBox="1"/>
           <p:nvPr/>
         </p:nvSpPr>
@@ -8656,7 +8475,7 @@
             <a:pPr algn="r">
               <a:defRPr sz="1100" b="0">
                 <a:solidFill>
-                  <a:srgbClr val="646464"/>
+                  <a:srgbClr val="22D3EE"/>
                 </a:solidFill>
                 <a:latin typeface="Consolas"/>
               </a:defRPr>
@@ -8700,6 +8519,123 @@
             <a:avLst/>
           </a:prstGeom>
           <a:solidFill>
+            <a:srgbClr val="FFDB15"/>
+          </a:solidFill>
+          <a:ln>
+            <a:noFill/>
+          </a:ln>
+        </p:spPr>
+        <p:style>
+          <a:lnRef idx="1">
+            <a:schemeClr val="accent1"/>
+          </a:lnRef>
+          <a:fillRef idx="3">
+            <a:schemeClr val="accent1"/>
+          </a:fillRef>
+          <a:effectRef idx="2">
+            <a:schemeClr val="accent1"/>
+          </a:effectRef>
+          <a:fontRef idx="minor">
+            <a:schemeClr val="lt1"/>
+          </a:fontRef>
+        </p:style>
+        <p:txBody>
+          <a:bodyPr rtlCol="0" anchor="ctr"/>
+          <a:lstStyle/>
+          <a:p>
+            <a:pPr algn="ctr"/>
+          </a:p>
+        </p:txBody>
+      </p:sp>
+      <p:sp>
+        <p:nvSpPr>
+          <p:cNvPr id="3" name="TextBox 2"/>
+          <p:cNvSpPr txBox="1"/>
+          <p:nvPr/>
+        </p:nvSpPr>
+        <p:spPr>
+          <a:xfrm>
+            <a:off x="1097280" y="1371600"/>
+            <a:ext cx="9144000" cy="914400"/>
+          </a:xfrm>
+          <a:prstGeom prst="rect">
+            <a:avLst/>
+          </a:prstGeom>
+          <a:noFill/>
+        </p:spPr>
+        <p:txBody>
+          <a:bodyPr wrap="square">
+            <a:spAutoFit/>
+          </a:bodyPr>
+          <a:lstStyle/>
+          <a:p>
+            <a:pPr algn="l">
+              <a:defRPr sz="4800" b="1">
+                <a:solidFill>
+                  <a:srgbClr val="000000"/>
+                </a:solidFill>
+                <a:latin typeface="Arial"/>
+              </a:defRPr>
+            </a:pPr>
+            <a:r>
+              <a:t>Why we win</a:t>
+            </a:r>
+          </a:p>
+        </p:txBody>
+      </p:sp>
+      <p:sp>
+        <p:nvSpPr>
+          <p:cNvPr id="4" name="TextBox 3"/>
+          <p:cNvSpPr txBox="1"/>
+          <p:nvPr/>
+        </p:nvSpPr>
+        <p:spPr>
+          <a:xfrm>
+            <a:off x="1097280" y="2286000"/>
+            <a:ext cx="10972800" cy="548640"/>
+          </a:xfrm>
+          <a:prstGeom prst="rect">
+            <a:avLst/>
+          </a:prstGeom>
+          <a:noFill/>
+        </p:spPr>
+        <p:txBody>
+          <a:bodyPr wrap="square">
+            <a:spAutoFit/>
+          </a:bodyPr>
+          <a:lstStyle/>
+          <a:p>
+            <a:pPr algn="l">
+              <a:defRPr sz="2000" b="0">
+                <a:solidFill>
+                  <a:srgbClr val="1E1E1E"/>
+                </a:solidFill>
+                <a:latin typeface="Arial"/>
+              </a:defRPr>
+            </a:pPr>
+            <a:r>
+              <a:t>Cognee raised $7.5M validating the category. We're simpler, faster, privacy-first.</a:t>
+            </a:r>
+          </a:p>
+        </p:txBody>
+      </p:sp>
+      <p:sp>
+        <p:nvSpPr>
+          <p:cNvPr id="5" name="Rounded Rectangle 4"/>
+          <p:cNvSpPr/>
+          <p:nvPr/>
+        </p:nvSpPr>
+        <p:spPr>
+          <a:xfrm>
+            <a:off x="1097280" y="3200400"/>
+            <a:ext cx="12344400" cy="3840480"/>
+          </a:xfrm>
+          <a:prstGeom prst="roundRect">
+            <a:avLst>
+              <a:gd name="adj" fmla="val 5000"/>
+            </a:avLst>
+          </a:prstGeom>
+          <a:solidFill>
             <a:srgbClr val="000000"/>
           </a:solidFill>
           <a:ln>
@@ -8730,28 +8666,205 @@
       </p:sp>
       <p:sp>
         <p:nvSpPr>
-          <p:cNvPr id="3" name="TextBox 2"/>
-          <p:cNvSpPr txBox="1"/>
-          <p:nvPr/>
-        </p:nvSpPr>
-        <p:spPr>
-          <a:xfrm>
-            <a:off x="1097280" y="1371600"/>
-            <a:ext cx="9144000" cy="914400"/>
-          </a:xfrm>
-          <a:prstGeom prst="rect">
-            <a:avLst/>
-          </a:prstGeom>
-          <a:noFill/>
-        </p:spPr>
-        <p:txBody>
-          <a:bodyPr wrap="square">
-            <a:spAutoFit/>
-          </a:bodyPr>
-          <a:lstStyle/>
-          <a:p>
-            <a:pPr algn="l">
-              <a:defRPr sz="4800" b="1">
+          <p:cNvPr id="6" name="TextBox 5"/>
+          <p:cNvSpPr txBox="1"/>
+          <p:nvPr/>
+        </p:nvSpPr>
+        <p:spPr>
+          <a:xfrm>
+            <a:off x="1371600" y="3383280"/>
+            <a:ext cx="3200400" cy="365760"/>
+          </a:xfrm>
+          <a:prstGeom prst="rect">
+            <a:avLst/>
+          </a:prstGeom>
+          <a:noFill/>
+        </p:spPr>
+        <p:txBody>
+          <a:bodyPr wrap="square">
+            <a:spAutoFit/>
+          </a:bodyPr>
+          <a:lstStyle/>
+          <a:p>
+            <a:pPr algn="l">
+              <a:defRPr sz="1400" b="0">
+                <a:solidFill>
+                  <a:srgbClr val="646464"/>
+                </a:solidFill>
+                <a:latin typeface="Arial"/>
+              </a:defRPr>
+            </a:pPr>
+          </a:p>
+        </p:txBody>
+      </p:sp>
+      <p:sp>
+        <p:nvSpPr>
+          <p:cNvPr id="7" name="TextBox 6"/>
+          <p:cNvSpPr txBox="1"/>
+          <p:nvPr/>
+        </p:nvSpPr>
+        <p:spPr>
+          <a:xfrm>
+            <a:off x="4754880" y="3383280"/>
+            <a:ext cx="3200400" cy="365760"/>
+          </a:xfrm>
+          <a:prstGeom prst="rect">
+            <a:avLst/>
+          </a:prstGeom>
+          <a:noFill/>
+        </p:spPr>
+        <p:txBody>
+          <a:bodyPr wrap="square">
+            <a:spAutoFit/>
+          </a:bodyPr>
+          <a:lstStyle/>
+          <a:p>
+            <a:pPr algn="l">
+              <a:defRPr sz="1400" b="1">
+                <a:solidFill>
+                  <a:srgbClr val="646464"/>
+                </a:solidFill>
+                <a:latin typeface="Arial"/>
+              </a:defRPr>
+            </a:pPr>
+            <a:r>
+              <a:t>Cognee</a:t>
+            </a:r>
+          </a:p>
+        </p:txBody>
+      </p:sp>
+      <p:sp>
+        <p:nvSpPr>
+          <p:cNvPr id="8" name="TextBox 7"/>
+          <p:cNvSpPr txBox="1"/>
+          <p:nvPr/>
+        </p:nvSpPr>
+        <p:spPr>
+          <a:xfrm>
+            <a:off x="8686800" y="3383280"/>
+            <a:ext cx="3200400" cy="365760"/>
+          </a:xfrm>
+          <a:prstGeom prst="rect">
+            <a:avLst/>
+          </a:prstGeom>
+          <a:noFill/>
+        </p:spPr>
+        <p:txBody>
+          <a:bodyPr wrap="square">
+            <a:spAutoFit/>
+          </a:bodyPr>
+          <a:lstStyle/>
+          <a:p>
+            <a:pPr algn="l">
+              <a:defRPr sz="1400" b="1">
+                <a:solidFill>
+                  <a:srgbClr val="646464"/>
+                </a:solidFill>
+                <a:latin typeface="Arial"/>
+              </a:defRPr>
+            </a:pPr>
+            <a:r>
+              <a:t>Mem0</a:t>
+            </a:r>
+          </a:p>
+        </p:txBody>
+      </p:sp>
+      <p:sp>
+        <p:nvSpPr>
+          <p:cNvPr id="9" name="TextBox 8"/>
+          <p:cNvSpPr txBox="1"/>
+          <p:nvPr/>
+        </p:nvSpPr>
+        <p:spPr>
+          <a:xfrm>
+            <a:off x="11430000" y="3383280"/>
+            <a:ext cx="1828800" cy="365760"/>
+          </a:xfrm>
+          <a:prstGeom prst="rect">
+            <a:avLst/>
+          </a:prstGeom>
+          <a:noFill/>
+        </p:spPr>
+        <p:txBody>
+          <a:bodyPr wrap="square">
+            <a:spAutoFit/>
+          </a:bodyPr>
+          <a:lstStyle/>
+          <a:p>
+            <a:pPr algn="l">
+              <a:defRPr sz="1400" b="1">
+                <a:solidFill>
+                  <a:srgbClr val="FFDB15"/>
+                </a:solidFill>
+                <a:latin typeface="Arial"/>
+              </a:defRPr>
+            </a:pPr>
+            <a:r>
+              <a:t>Engrm</a:t>
+            </a:r>
+          </a:p>
+        </p:txBody>
+      </p:sp>
+      <p:sp>
+        <p:nvSpPr>
+          <p:cNvPr id="10" name="TextBox 9"/>
+          <p:cNvSpPr txBox="1"/>
+          <p:nvPr/>
+        </p:nvSpPr>
+        <p:spPr>
+          <a:xfrm>
+            <a:off x="1371600" y="3840480"/>
+            <a:ext cx="3200400" cy="457200"/>
+          </a:xfrm>
+          <a:prstGeom prst="rect">
+            <a:avLst/>
+          </a:prstGeom>
+          <a:noFill/>
+        </p:spPr>
+        <p:txBody>
+          <a:bodyPr wrap="square">
+            <a:spAutoFit/>
+          </a:bodyPr>
+          <a:lstStyle/>
+          <a:p>
+            <a:pPr algn="l">
+              <a:defRPr sz="1200" b="0">
+                <a:solidFill>
+                  <a:srgbClr val="646464"/>
+                </a:solidFill>
+                <a:latin typeface="Arial"/>
+              </a:defRPr>
+            </a:pPr>
+            <a:r>
+              <a:t>Setup</a:t>
+            </a:r>
+          </a:p>
+        </p:txBody>
+      </p:sp>
+      <p:sp>
+        <p:nvSpPr>
+          <p:cNvPr id="11" name="TextBox 10"/>
+          <p:cNvSpPr txBox="1"/>
+          <p:nvPr/>
+        </p:nvSpPr>
+        <p:spPr>
+          <a:xfrm>
+            <a:off x="4754880" y="3840480"/>
+            <a:ext cx="3200400" cy="457200"/>
+          </a:xfrm>
+          <a:prstGeom prst="rect">
+            <a:avLst/>
+          </a:prstGeom>
+          <a:noFill/>
+        </p:spPr>
+        <p:txBody>
+          <a:bodyPr wrap="square">
+            <a:spAutoFit/>
+          </a:bodyPr>
+          <a:lstStyle/>
+          <a:p>
+            <a:pPr algn="l">
+              <a:defRPr sz="1200" b="0">
                 <a:solidFill>
                   <a:srgbClr val="FFFFFF"/>
                 </a:solidFill>
@@ -8759,35 +8872,107 @@
               </a:defRPr>
             </a:pPr>
             <a:r>
-              <a:t>Developer experience</a:t>
-            </a:r>
-          </a:p>
-        </p:txBody>
-      </p:sp>
-      <p:sp>
-        <p:nvSpPr>
-          <p:cNvPr id="4" name="TextBox 3"/>
-          <p:cNvSpPr txBox="1"/>
-          <p:nvPr/>
-        </p:nvSpPr>
-        <p:spPr>
-          <a:xfrm>
-            <a:off x="1097280" y="2377440"/>
-            <a:ext cx="9144000" cy="548640"/>
-          </a:xfrm>
-          <a:prstGeom prst="rect">
-            <a:avLst/>
-          </a:prstGeom>
-          <a:noFill/>
-        </p:spPr>
-        <p:txBody>
-          <a:bodyPr wrap="square">
-            <a:spAutoFit/>
-          </a:bodyPr>
-          <a:lstStyle/>
-          <a:p>
-            <a:pPr algn="l">
-              <a:defRPr sz="2000" b="0">
+              <a:t>Days</a:t>
+            </a:r>
+          </a:p>
+        </p:txBody>
+      </p:sp>
+      <p:sp>
+        <p:nvSpPr>
+          <p:cNvPr id="12" name="TextBox 11"/>
+          <p:cNvSpPr txBox="1"/>
+          <p:nvPr/>
+        </p:nvSpPr>
+        <p:spPr>
+          <a:xfrm>
+            <a:off x="8686800" y="3840480"/>
+            <a:ext cx="2286000" cy="457200"/>
+          </a:xfrm>
+          <a:prstGeom prst="rect">
+            <a:avLst/>
+          </a:prstGeom>
+          <a:noFill/>
+        </p:spPr>
+        <p:txBody>
+          <a:bodyPr wrap="square">
+            <a:spAutoFit/>
+          </a:bodyPr>
+          <a:lstStyle/>
+          <a:p>
+            <a:pPr algn="l">
+              <a:defRPr sz="1200" b="0">
+                <a:solidFill>
+                  <a:srgbClr val="FFFFFF"/>
+                </a:solidFill>
+                <a:latin typeface="Arial"/>
+              </a:defRPr>
+            </a:pPr>
+            <a:r>
+              <a:t>Minutes</a:t>
+            </a:r>
+          </a:p>
+        </p:txBody>
+      </p:sp>
+      <p:sp>
+        <p:nvSpPr>
+          <p:cNvPr id="13" name="TextBox 12"/>
+          <p:cNvSpPr txBox="1"/>
+          <p:nvPr/>
+        </p:nvSpPr>
+        <p:spPr>
+          <a:xfrm>
+            <a:off x="11430000" y="3840480"/>
+            <a:ext cx="1828800" cy="457200"/>
+          </a:xfrm>
+          <a:prstGeom prst="rect">
+            <a:avLst/>
+          </a:prstGeom>
+          <a:noFill/>
+        </p:spPr>
+        <p:txBody>
+          <a:bodyPr wrap="square">
+            <a:spAutoFit/>
+          </a:bodyPr>
+          <a:lstStyle/>
+          <a:p>
+            <a:pPr algn="l">
+              <a:defRPr sz="1200" b="0">
+                <a:solidFill>
+                  <a:srgbClr val="FFDB15"/>
+                </a:solidFill>
+                <a:latin typeface="Arial"/>
+              </a:defRPr>
+            </a:pPr>
+            <a:r>
+              <a:t>Minutes</a:t>
+            </a:r>
+          </a:p>
+        </p:txBody>
+      </p:sp>
+      <p:sp>
+        <p:nvSpPr>
+          <p:cNvPr id="14" name="TextBox 13"/>
+          <p:cNvSpPr txBox="1"/>
+          <p:nvPr/>
+        </p:nvSpPr>
+        <p:spPr>
+          <a:xfrm>
+            <a:off x="1371600" y="4343400"/>
+            <a:ext cx="3200400" cy="457200"/>
+          </a:xfrm>
+          <a:prstGeom prst="rect">
+            <a:avLst/>
+          </a:prstGeom>
+          <a:noFill/>
+        </p:spPr>
+        <p:txBody>
+          <a:bodyPr wrap="square">
+            <a:spAutoFit/>
+          </a:bodyPr>
+          <a:lstStyle/>
+          <a:p>
+            <a:pPr algn="l">
+              <a:defRPr sz="1200" b="0">
                 <a:solidFill>
                   <a:srgbClr val="646464"/>
                 </a:solidFill>
@@ -8795,82 +8980,107 @@
               </a:defRPr>
             </a:pPr>
             <a:r>
-              <a:t>Memory should feel automatic. Integration in minutes.</a:t>
-            </a:r>
-          </a:p>
-        </p:txBody>
-      </p:sp>
-      <p:sp>
-        <p:nvSpPr>
-          <p:cNvPr id="5" name="Rounded Rectangle 4"/>
-          <p:cNvSpPr/>
-          <p:nvPr/>
-        </p:nvSpPr>
-        <p:spPr>
-          <a:xfrm>
-            <a:off x="1097280" y="3200400"/>
-            <a:ext cx="6400800" cy="3657600"/>
-          </a:xfrm>
-          <a:prstGeom prst="roundRect">
-            <a:avLst>
-              <a:gd name="adj" fmla="val 5000"/>
-            </a:avLst>
-          </a:prstGeom>
-          <a:solidFill>
-            <a:srgbClr val="1E1E1E"/>
-          </a:solidFill>
-          <a:ln w="25400">
-            <a:solidFill>
-              <a:srgbClr val="FFDB15"/>
-            </a:solidFill>
-          </a:ln>
-        </p:spPr>
-        <p:style>
-          <a:lnRef idx="1">
-            <a:schemeClr val="accent1"/>
-          </a:lnRef>
-          <a:fillRef idx="3">
-            <a:schemeClr val="accent1"/>
-          </a:fillRef>
-          <a:effectRef idx="2">
-            <a:schemeClr val="accent1"/>
-          </a:effectRef>
-          <a:fontRef idx="minor">
-            <a:schemeClr val="lt1"/>
-          </a:fontRef>
-        </p:style>
-        <p:txBody>
-          <a:bodyPr rtlCol="0" anchor="ctr"/>
-          <a:lstStyle/>
-          <a:p>
-            <a:pPr algn="ctr"/>
-          </a:p>
-        </p:txBody>
-      </p:sp>
-      <p:sp>
-        <p:nvSpPr>
-          <p:cNvPr id="6" name="TextBox 5"/>
-          <p:cNvSpPr txBox="1"/>
-          <p:nvPr/>
-        </p:nvSpPr>
-        <p:spPr>
-          <a:xfrm>
-            <a:off x="1371600" y="3383280"/>
-            <a:ext cx="5486400" cy="457200"/>
-          </a:xfrm>
-          <a:prstGeom prst="rect">
-            <a:avLst/>
-          </a:prstGeom>
-          <a:noFill/>
-        </p:spPr>
-        <p:txBody>
-          <a:bodyPr wrap="square">
-            <a:spAutoFit/>
-          </a:bodyPr>
-          <a:lstStyle/>
-          <a:p>
-            <a:pPr algn="l">
-              <a:defRPr sz="1800" b="1">
+              <a:t>Integration</a:t>
+            </a:r>
+          </a:p>
+        </p:txBody>
+      </p:sp>
+      <p:sp>
+        <p:nvSpPr>
+          <p:cNvPr id="15" name="TextBox 14"/>
+          <p:cNvSpPr txBox="1"/>
+          <p:nvPr/>
+        </p:nvSpPr>
+        <p:spPr>
+          <a:xfrm>
+            <a:off x="4754880" y="4343400"/>
+            <a:ext cx="3200400" cy="457200"/>
+          </a:xfrm>
+          <a:prstGeom prst="rect">
+            <a:avLst/>
+          </a:prstGeom>
+          <a:noFill/>
+        </p:spPr>
+        <p:txBody>
+          <a:bodyPr wrap="square">
+            <a:spAutoFit/>
+          </a:bodyPr>
+          <a:lstStyle/>
+          <a:p>
+            <a:pPr algn="l">
+              <a:defRPr sz="1200" b="0">
+                <a:solidFill>
+                  <a:srgbClr val="FFFFFF"/>
+                </a:solidFill>
+                <a:latin typeface="Arial"/>
+              </a:defRPr>
+            </a:pPr>
+            <a:r>
+              <a:t>ECL pipeline</a:t>
+            </a:r>
+          </a:p>
+        </p:txBody>
+      </p:sp>
+      <p:sp>
+        <p:nvSpPr>
+          <p:cNvPr id="16" name="TextBox 15"/>
+          <p:cNvSpPr txBox="1"/>
+          <p:nvPr/>
+        </p:nvSpPr>
+        <p:spPr>
+          <a:xfrm>
+            <a:off x="8686800" y="4343400"/>
+            <a:ext cx="2286000" cy="457200"/>
+          </a:xfrm>
+          <a:prstGeom prst="rect">
+            <a:avLst/>
+          </a:prstGeom>
+          <a:noFill/>
+        </p:spPr>
+        <p:txBody>
+          <a:bodyPr wrap="square">
+            <a:spAutoFit/>
+          </a:bodyPr>
+          <a:lstStyle/>
+          <a:p>
+            <a:pPr algn="l">
+              <a:defRPr sz="1200" b="0">
+                <a:solidFill>
+                  <a:srgbClr val="FFFFFF"/>
+                </a:solidFill>
+                <a:latin typeface="Arial"/>
+              </a:defRPr>
+            </a:pPr>
+            <a:r>
+              <a:t>Simple API</a:t>
+            </a:r>
+          </a:p>
+        </p:txBody>
+      </p:sp>
+      <p:sp>
+        <p:nvSpPr>
+          <p:cNvPr id="17" name="TextBox 16"/>
+          <p:cNvSpPr txBox="1"/>
+          <p:nvPr/>
+        </p:nvSpPr>
+        <p:spPr>
+          <a:xfrm>
+            <a:off x="11430000" y="4343400"/>
+            <a:ext cx="1828800" cy="457200"/>
+          </a:xfrm>
+          <a:prstGeom prst="rect">
+            <a:avLst/>
+          </a:prstGeom>
+          <a:noFill/>
+        </p:spPr>
+        <p:txBody>
+          <a:bodyPr wrap="square">
+            <a:spAutoFit/>
+          </a:bodyPr>
+          <a:lstStyle/>
+          <a:p>
+            <a:pPr algn="l">
+              <a:defRPr sz="1200" b="0">
                 <a:solidFill>
                   <a:srgbClr val="FFDB15"/>
                 </a:solidFill>
@@ -8878,148 +9088,107 @@
               </a:defRPr>
             </a:pPr>
             <a:r>
-              <a:t>Python SDK</a:t>
-            </a:r>
-          </a:p>
-        </p:txBody>
-      </p:sp>
-      <p:sp>
-        <p:nvSpPr>
-          <p:cNvPr id="7" name="TextBox 6"/>
-          <p:cNvSpPr txBox="1"/>
-          <p:nvPr/>
-        </p:nvSpPr>
-        <p:spPr>
-          <a:xfrm>
-            <a:off x="1371600" y="3931920"/>
-            <a:ext cx="5943600" cy="2743200"/>
-          </a:xfrm>
-          <a:prstGeom prst="rect">
-            <a:avLst/>
-          </a:prstGeom>
-          <a:noFill/>
-        </p:spPr>
-        <p:txBody>
-          <a:bodyPr wrap="square">
-            <a:spAutoFit/>
-          </a:bodyPr>
-          <a:lstStyle/>
-          <a:p>
-            <a:pPr algn="l">
-              <a:defRPr sz="1100" b="0">
+              <a:t>2 endpoints</a:t>
+            </a:r>
+          </a:p>
+        </p:txBody>
+      </p:sp>
+      <p:sp>
+        <p:nvSpPr>
+          <p:cNvPr id="18" name="TextBox 17"/>
+          <p:cNvSpPr txBox="1"/>
+          <p:nvPr/>
+        </p:nvSpPr>
+        <p:spPr>
+          <a:xfrm>
+            <a:off x="1371600" y="4846320"/>
+            <a:ext cx="3200400" cy="457200"/>
+          </a:xfrm>
+          <a:prstGeom prst="rect">
+            <a:avLst/>
+          </a:prstGeom>
+          <a:noFill/>
+        </p:spPr>
+        <p:txBody>
+          <a:bodyPr wrap="square">
+            <a:spAutoFit/>
+          </a:bodyPr>
+          <a:lstStyle/>
+          <a:p>
+            <a:pPr algn="l">
+              <a:defRPr sz="1200" b="0">
+                <a:solidFill>
+                  <a:srgbClr val="646464"/>
+                </a:solidFill>
+                <a:latin typeface="Arial"/>
+              </a:defRPr>
+            </a:pPr>
+            <a:r>
+              <a:t>Model lock-in</a:t>
+            </a:r>
+          </a:p>
+        </p:txBody>
+      </p:sp>
+      <p:sp>
+        <p:nvSpPr>
+          <p:cNvPr id="19" name="TextBox 18"/>
+          <p:cNvSpPr txBox="1"/>
+          <p:nvPr/>
+        </p:nvSpPr>
+        <p:spPr>
+          <a:xfrm>
+            <a:off x="4754880" y="4846320"/>
+            <a:ext cx="3200400" cy="457200"/>
+          </a:xfrm>
+          <a:prstGeom prst="rect">
+            <a:avLst/>
+          </a:prstGeom>
+          <a:noFill/>
+        </p:spPr>
+        <p:txBody>
+          <a:bodyPr wrap="square">
+            <a:spAutoFit/>
+          </a:bodyPr>
+          <a:lstStyle/>
+          <a:p>
+            <a:pPr algn="l">
+              <a:defRPr sz="1200" b="0">
                 <a:solidFill>
                   <a:srgbClr val="FFFFFF"/>
                 </a:solidFill>
-                <a:latin typeface="Consolas"/>
-              </a:defRPr>
-            </a:pPr>
-            <a:r>
-              <a:t>from engrm import Engrm</a:t>
-            </a:r>
-            <a:br/>
-            <a:br/>
-            <a:r>
-              <a:t>client = Engrm(api_key="mem_...")</a:t>
-            </a:r>
-            <a:br/>
-            <a:br/>
-            <a:r>
-              <a:t># Store automatically</a:t>
-            </a:r>
-            <a:br/>
-            <a:r>
-              <a:t>client.store("User loves hiking")</a:t>
-            </a:r>
-            <a:br/>
-            <a:br/>
-            <a:r>
-              <a:t># Recall with context</a:t>
-            </a:r>
-            <a:br/>
-            <a:r>
-              <a:t>memories = client.search("outdoor activities")</a:t>
-            </a:r>
-            <a:br/>
-            <a:br/>
-            <a:r>
-              <a:t># Inject into prompt</a:t>
-            </a:r>
-            <a:br/>
-            <a:r>
-              <a:t>context = client.context()</a:t>
-            </a:r>
-          </a:p>
-        </p:txBody>
-      </p:sp>
-      <p:sp>
-        <p:nvSpPr>
-          <p:cNvPr id="8" name="Rounded Rectangle 7"/>
-          <p:cNvSpPr/>
-          <p:nvPr/>
-        </p:nvSpPr>
-        <p:spPr>
-          <a:xfrm>
-            <a:off x="7955279" y="3200400"/>
-            <a:ext cx="5760720" cy="3657600"/>
-          </a:xfrm>
-          <a:prstGeom prst="roundRect">
-            <a:avLst>
-              <a:gd name="adj" fmla="val 5000"/>
-            </a:avLst>
-          </a:prstGeom>
-          <a:solidFill>
-            <a:srgbClr val="1E1E1E"/>
-          </a:solidFill>
-          <a:ln>
-            <a:noFill/>
-          </a:ln>
-        </p:spPr>
-        <p:style>
-          <a:lnRef idx="1">
-            <a:schemeClr val="accent1"/>
-          </a:lnRef>
-          <a:fillRef idx="3">
-            <a:schemeClr val="accent1"/>
-          </a:fillRef>
-          <a:effectRef idx="2">
-            <a:schemeClr val="accent1"/>
-          </a:effectRef>
-          <a:fontRef idx="minor">
-            <a:schemeClr val="lt1"/>
-          </a:fontRef>
-        </p:style>
-        <p:txBody>
-          <a:bodyPr rtlCol="0" anchor="ctr"/>
-          <a:lstStyle/>
-          <a:p>
-            <a:pPr algn="ctr"/>
-          </a:p>
-        </p:txBody>
-      </p:sp>
-      <p:sp>
-        <p:nvSpPr>
-          <p:cNvPr id="9" name="TextBox 8"/>
-          <p:cNvSpPr txBox="1"/>
-          <p:nvPr/>
-        </p:nvSpPr>
-        <p:spPr>
-          <a:xfrm>
-            <a:off x="8229600" y="3383280"/>
-            <a:ext cx="5029200" cy="457200"/>
-          </a:xfrm>
-          <a:prstGeom prst="rect">
-            <a:avLst/>
-          </a:prstGeom>
-          <a:noFill/>
-        </p:spPr>
-        <p:txBody>
-          <a:bodyPr wrap="square">
-            <a:spAutoFit/>
-          </a:bodyPr>
-          <a:lstStyle/>
-          <a:p>
-            <a:pPr algn="l">
-              <a:defRPr sz="1800" b="1">
+                <a:latin typeface="Arial"/>
+              </a:defRPr>
+            </a:pPr>
+            <a:r>
+              <a:t>None</a:t>
+            </a:r>
+          </a:p>
+        </p:txBody>
+      </p:sp>
+      <p:sp>
+        <p:nvSpPr>
+          <p:cNvPr id="20" name="TextBox 19"/>
+          <p:cNvSpPr txBox="1"/>
+          <p:nvPr/>
+        </p:nvSpPr>
+        <p:spPr>
+          <a:xfrm>
+            <a:off x="8686800" y="4846320"/>
+            <a:ext cx="2286000" cy="457200"/>
+          </a:xfrm>
+          <a:prstGeom prst="rect">
+            <a:avLst/>
+          </a:prstGeom>
+          <a:noFill/>
+        </p:spPr>
+        <p:txBody>
+          <a:bodyPr wrap="square">
+            <a:spAutoFit/>
+          </a:bodyPr>
+          <a:lstStyle/>
+          <a:p>
+            <a:pPr algn="l">
+              <a:defRPr sz="1200" b="0">
                 <a:solidFill>
                   <a:srgbClr val="FFFFFF"/>
                 </a:solidFill>
@@ -9027,35 +9196,71 @@
               </a:defRPr>
             </a:pPr>
             <a:r>
-              <a:t>What you get</a:t>
-            </a:r>
-          </a:p>
-        </p:txBody>
-      </p:sp>
-      <p:sp>
-        <p:nvSpPr>
-          <p:cNvPr id="10" name="TextBox 9"/>
-          <p:cNvSpPr txBox="1"/>
-          <p:nvPr/>
-        </p:nvSpPr>
-        <p:spPr>
-          <a:xfrm>
-            <a:off x="8229600" y="3931920"/>
-            <a:ext cx="5303520" cy="2743200"/>
-          </a:xfrm>
-          <a:prstGeom prst="rect">
-            <a:avLst/>
-          </a:prstGeom>
-          <a:noFill/>
-        </p:spPr>
-        <p:txBody>
-          <a:bodyPr wrap="square">
-            <a:spAutoFit/>
-          </a:bodyPr>
-          <a:lstStyle/>
-          <a:p>
-            <a:pPr algn="l">
-              <a:defRPr sz="1300" b="0">
+              <a:t>None</a:t>
+            </a:r>
+          </a:p>
+        </p:txBody>
+      </p:sp>
+      <p:sp>
+        <p:nvSpPr>
+          <p:cNvPr id="21" name="TextBox 20"/>
+          <p:cNvSpPr txBox="1"/>
+          <p:nvPr/>
+        </p:nvSpPr>
+        <p:spPr>
+          <a:xfrm>
+            <a:off x="11430000" y="4846320"/>
+            <a:ext cx="1828800" cy="457200"/>
+          </a:xfrm>
+          <a:prstGeom prst="rect">
+            <a:avLst/>
+          </a:prstGeom>
+          <a:noFill/>
+        </p:spPr>
+        <p:txBody>
+          <a:bodyPr wrap="square">
+            <a:spAutoFit/>
+          </a:bodyPr>
+          <a:lstStyle/>
+          <a:p>
+            <a:pPr algn="l">
+              <a:defRPr sz="1200" b="0">
+                <a:solidFill>
+                  <a:srgbClr val="FFDB15"/>
+                </a:solidFill>
+                <a:latin typeface="Arial"/>
+              </a:defRPr>
+            </a:pPr>
+            <a:r>
+              <a:t>None ✓</a:t>
+            </a:r>
+          </a:p>
+        </p:txBody>
+      </p:sp>
+      <p:sp>
+        <p:nvSpPr>
+          <p:cNvPr id="22" name="TextBox 21"/>
+          <p:cNvSpPr txBox="1"/>
+          <p:nvPr/>
+        </p:nvSpPr>
+        <p:spPr>
+          <a:xfrm>
+            <a:off x="1371600" y="5349240"/>
+            <a:ext cx="3200400" cy="457200"/>
+          </a:xfrm>
+          <a:prstGeom prst="rect">
+            <a:avLst/>
+          </a:prstGeom>
+          <a:noFill/>
+        </p:spPr>
+        <p:txBody>
+          <a:bodyPr wrap="square">
+            <a:spAutoFit/>
+          </a:bodyPr>
+          <a:lstStyle/>
+          <a:p>
+            <a:pPr algn="l">
+              <a:defRPr sz="1200" b="0">
                 <a:solidFill>
                   <a:srgbClr val="646464"/>
                 </a:solidFill>
@@ -9063,42 +9268,410 @@
               </a:defRPr>
             </a:pPr>
             <a:r>
-              <a:t>✓ Auto memory classification</a:t>
-            </a:r>
-            <a:br/>
-            <a:r>
-              <a:t>✓ Entity extraction included</a:t>
-            </a:r>
-            <a:br/>
-            <a:r>
-              <a:t>✓ Semantic + keyword search</a:t>
-            </a:r>
-            <a:br/>
-            <a:r>
-              <a:t>✓ Token-optimized context</a:t>
-            </a:r>
-            <a:br/>
-            <a:r>
-              <a:t>✓ Memory Browser dashboard</a:t>
-            </a:r>
-            <a:br/>
-            <a:r>
-              <a:t>✓ Usage analytics</a:t>
-            </a:r>
-            <a:br/>
-            <a:r>
-              <a:t>✓ MCP server for Claude</a:t>
-            </a:r>
-            <a:br/>
-            <a:r>
-              <a:t>✓ REST API + TypeScript SDK</a:t>
-            </a:r>
-          </a:p>
-        </p:txBody>
-      </p:sp>
-      <p:sp>
-        <p:nvSpPr>
-          <p:cNvPr id="11" name="TextBox 10"/>
+              <a:t>Encryption</a:t>
+            </a:r>
+          </a:p>
+        </p:txBody>
+      </p:sp>
+      <p:sp>
+        <p:nvSpPr>
+          <p:cNvPr id="23" name="TextBox 22"/>
+          <p:cNvSpPr txBox="1"/>
+          <p:nvPr/>
+        </p:nvSpPr>
+        <p:spPr>
+          <a:xfrm>
+            <a:off x="4754880" y="5349240"/>
+            <a:ext cx="3200400" cy="457200"/>
+          </a:xfrm>
+          <a:prstGeom prst="rect">
+            <a:avLst/>
+          </a:prstGeom>
+          <a:noFill/>
+        </p:spPr>
+        <p:txBody>
+          <a:bodyPr wrap="square">
+            <a:spAutoFit/>
+          </a:bodyPr>
+          <a:lstStyle/>
+          <a:p>
+            <a:pPr algn="l">
+              <a:defRPr sz="1200" b="0">
+                <a:solidFill>
+                  <a:srgbClr val="FFFFFF"/>
+                </a:solidFill>
+                <a:latin typeface="Arial"/>
+              </a:defRPr>
+            </a:pPr>
+            <a:r>
+              <a:t>Enterprise tier</a:t>
+            </a:r>
+          </a:p>
+        </p:txBody>
+      </p:sp>
+      <p:sp>
+        <p:nvSpPr>
+          <p:cNvPr id="24" name="TextBox 23"/>
+          <p:cNvSpPr txBox="1"/>
+          <p:nvPr/>
+        </p:nvSpPr>
+        <p:spPr>
+          <a:xfrm>
+            <a:off x="8686800" y="5349240"/>
+            <a:ext cx="2286000" cy="457200"/>
+          </a:xfrm>
+          <a:prstGeom prst="rect">
+            <a:avLst/>
+          </a:prstGeom>
+          <a:noFill/>
+        </p:spPr>
+        <p:txBody>
+          <a:bodyPr wrap="square">
+            <a:spAutoFit/>
+          </a:bodyPr>
+          <a:lstStyle/>
+          <a:p>
+            <a:pPr algn="l">
+              <a:defRPr sz="1200" b="0">
+                <a:solidFill>
+                  <a:srgbClr val="FFFFFF"/>
+                </a:solidFill>
+                <a:latin typeface="Arial"/>
+              </a:defRPr>
+            </a:pPr>
+            <a:r>
+              <a:t>Optional</a:t>
+            </a:r>
+          </a:p>
+        </p:txBody>
+      </p:sp>
+      <p:sp>
+        <p:nvSpPr>
+          <p:cNvPr id="25" name="TextBox 24"/>
+          <p:cNvSpPr txBox="1"/>
+          <p:nvPr/>
+        </p:nvSpPr>
+        <p:spPr>
+          <a:xfrm>
+            <a:off x="11430000" y="5349240"/>
+            <a:ext cx="1828800" cy="457200"/>
+          </a:xfrm>
+          <a:prstGeom prst="rect">
+            <a:avLst/>
+          </a:prstGeom>
+          <a:noFill/>
+        </p:spPr>
+        <p:txBody>
+          <a:bodyPr wrap="square">
+            <a:spAutoFit/>
+          </a:bodyPr>
+          <a:lstStyle/>
+          <a:p>
+            <a:pPr algn="l">
+              <a:defRPr sz="1200" b="0">
+                <a:solidFill>
+                  <a:srgbClr val="FFDB15"/>
+                </a:solidFill>
+                <a:latin typeface="Arial"/>
+              </a:defRPr>
+            </a:pPr>
+            <a:r>
+              <a:t>Default ✓</a:t>
+            </a:r>
+          </a:p>
+        </p:txBody>
+      </p:sp>
+      <p:sp>
+        <p:nvSpPr>
+          <p:cNvPr id="26" name="TextBox 25"/>
+          <p:cNvSpPr txBox="1"/>
+          <p:nvPr/>
+        </p:nvSpPr>
+        <p:spPr>
+          <a:xfrm>
+            <a:off x="1371600" y="5852160"/>
+            <a:ext cx="3200400" cy="457200"/>
+          </a:xfrm>
+          <a:prstGeom prst="rect">
+            <a:avLst/>
+          </a:prstGeom>
+          <a:noFill/>
+        </p:spPr>
+        <p:txBody>
+          <a:bodyPr wrap="square">
+            <a:spAutoFit/>
+          </a:bodyPr>
+          <a:lstStyle/>
+          <a:p>
+            <a:pPr algn="l">
+              <a:defRPr sz="1200" b="0">
+                <a:solidFill>
+                  <a:srgbClr val="646464"/>
+                </a:solidFill>
+                <a:latin typeface="Arial"/>
+              </a:defRPr>
+            </a:pPr>
+            <a:r>
+              <a:t>Cross-platform</a:t>
+            </a:r>
+          </a:p>
+        </p:txBody>
+      </p:sp>
+      <p:sp>
+        <p:nvSpPr>
+          <p:cNvPr id="27" name="TextBox 26"/>
+          <p:cNvSpPr txBox="1"/>
+          <p:nvPr/>
+        </p:nvSpPr>
+        <p:spPr>
+          <a:xfrm>
+            <a:off x="4754880" y="5852160"/>
+            <a:ext cx="3200400" cy="457200"/>
+          </a:xfrm>
+          <a:prstGeom prst="rect">
+            <a:avLst/>
+          </a:prstGeom>
+          <a:noFill/>
+        </p:spPr>
+        <p:txBody>
+          <a:bodyPr wrap="square">
+            <a:spAutoFit/>
+          </a:bodyPr>
+          <a:lstStyle/>
+          <a:p>
+            <a:pPr algn="l">
+              <a:defRPr sz="1200" b="0">
+                <a:solidFill>
+                  <a:srgbClr val="FFFFFF"/>
+                </a:solidFill>
+                <a:latin typeface="Arial"/>
+              </a:defRPr>
+            </a:pPr>
+            <a:r>
+              <a:t>API only</a:t>
+            </a:r>
+          </a:p>
+        </p:txBody>
+      </p:sp>
+      <p:sp>
+        <p:nvSpPr>
+          <p:cNvPr id="28" name="TextBox 27"/>
+          <p:cNvSpPr txBox="1"/>
+          <p:nvPr/>
+        </p:nvSpPr>
+        <p:spPr>
+          <a:xfrm>
+            <a:off x="8686800" y="5852160"/>
+            <a:ext cx="2286000" cy="457200"/>
+          </a:xfrm>
+          <a:prstGeom prst="rect">
+            <a:avLst/>
+          </a:prstGeom>
+          <a:noFill/>
+        </p:spPr>
+        <p:txBody>
+          <a:bodyPr wrap="square">
+            <a:spAutoFit/>
+          </a:bodyPr>
+          <a:lstStyle/>
+          <a:p>
+            <a:pPr algn="l">
+              <a:defRPr sz="1200" b="0">
+                <a:solidFill>
+                  <a:srgbClr val="FFFFFF"/>
+                </a:solidFill>
+                <a:latin typeface="Arial"/>
+              </a:defRPr>
+            </a:pPr>
+            <a:r>
+              <a:t>API only</a:t>
+            </a:r>
+          </a:p>
+        </p:txBody>
+      </p:sp>
+      <p:sp>
+        <p:nvSpPr>
+          <p:cNvPr id="29" name="TextBox 28"/>
+          <p:cNvSpPr txBox="1"/>
+          <p:nvPr/>
+        </p:nvSpPr>
+        <p:spPr>
+          <a:xfrm>
+            <a:off x="11430000" y="5852160"/>
+            <a:ext cx="1828800" cy="457200"/>
+          </a:xfrm>
+          <a:prstGeom prst="rect">
+            <a:avLst/>
+          </a:prstGeom>
+          <a:noFill/>
+        </p:spPr>
+        <p:txBody>
+          <a:bodyPr wrap="square">
+            <a:spAutoFit/>
+          </a:bodyPr>
+          <a:lstStyle/>
+          <a:p>
+            <a:pPr algn="l">
+              <a:defRPr sz="1200" b="0">
+                <a:solidFill>
+                  <a:srgbClr val="FFDB15"/>
+                </a:solidFill>
+                <a:latin typeface="Arial"/>
+              </a:defRPr>
+            </a:pPr>
+            <a:r>
+              <a:t>Built-in ✓</a:t>
+            </a:r>
+          </a:p>
+        </p:txBody>
+      </p:sp>
+      <p:sp>
+        <p:nvSpPr>
+          <p:cNvPr id="30" name="TextBox 29"/>
+          <p:cNvSpPr txBox="1"/>
+          <p:nvPr/>
+        </p:nvSpPr>
+        <p:spPr>
+          <a:xfrm>
+            <a:off x="1371600" y="6355080"/>
+            <a:ext cx="3200400" cy="457200"/>
+          </a:xfrm>
+          <a:prstGeom prst="rect">
+            <a:avLst/>
+          </a:prstGeom>
+          <a:noFill/>
+        </p:spPr>
+        <p:txBody>
+          <a:bodyPr wrap="square">
+            <a:spAutoFit/>
+          </a:bodyPr>
+          <a:lstStyle/>
+          <a:p>
+            <a:pPr algn="l">
+              <a:defRPr sz="1200" b="0">
+                <a:solidFill>
+                  <a:srgbClr val="646464"/>
+                </a:solidFill>
+                <a:latin typeface="Arial"/>
+              </a:defRPr>
+            </a:pPr>
+            <a:r>
+              <a:t>Privacy model</a:t>
+            </a:r>
+          </a:p>
+        </p:txBody>
+      </p:sp>
+      <p:sp>
+        <p:nvSpPr>
+          <p:cNvPr id="31" name="TextBox 30"/>
+          <p:cNvSpPr txBox="1"/>
+          <p:nvPr/>
+        </p:nvSpPr>
+        <p:spPr>
+          <a:xfrm>
+            <a:off x="4754880" y="6355080"/>
+            <a:ext cx="3200400" cy="457200"/>
+          </a:xfrm>
+          <a:prstGeom prst="rect">
+            <a:avLst/>
+          </a:prstGeom>
+          <a:noFill/>
+        </p:spPr>
+        <p:txBody>
+          <a:bodyPr wrap="square">
+            <a:spAutoFit/>
+          </a:bodyPr>
+          <a:lstStyle/>
+          <a:p>
+            <a:pPr algn="l">
+              <a:defRPr sz="1200" b="0">
+                <a:solidFill>
+                  <a:srgbClr val="FFFFFF"/>
+                </a:solidFill>
+                <a:latin typeface="Arial"/>
+              </a:defRPr>
+            </a:pPr>
+            <a:r>
+              <a:t>Standard</a:t>
+            </a:r>
+          </a:p>
+        </p:txBody>
+      </p:sp>
+      <p:sp>
+        <p:nvSpPr>
+          <p:cNvPr id="32" name="TextBox 31"/>
+          <p:cNvSpPr txBox="1"/>
+          <p:nvPr/>
+        </p:nvSpPr>
+        <p:spPr>
+          <a:xfrm>
+            <a:off x="8686800" y="6355080"/>
+            <a:ext cx="2286000" cy="457200"/>
+          </a:xfrm>
+          <a:prstGeom prst="rect">
+            <a:avLst/>
+          </a:prstGeom>
+          <a:noFill/>
+        </p:spPr>
+        <p:txBody>
+          <a:bodyPr wrap="square">
+            <a:spAutoFit/>
+          </a:bodyPr>
+          <a:lstStyle/>
+          <a:p>
+            <a:pPr algn="l">
+              <a:defRPr sz="1200" b="0">
+                <a:solidFill>
+                  <a:srgbClr val="FFFFFF"/>
+                </a:solidFill>
+                <a:latin typeface="Arial"/>
+              </a:defRPr>
+            </a:pPr>
+            <a:r>
+              <a:t>Standard</a:t>
+            </a:r>
+          </a:p>
+        </p:txBody>
+      </p:sp>
+      <p:sp>
+        <p:nvSpPr>
+          <p:cNvPr id="33" name="TextBox 32"/>
+          <p:cNvSpPr txBox="1"/>
+          <p:nvPr/>
+        </p:nvSpPr>
+        <p:spPr>
+          <a:xfrm>
+            <a:off x="11430000" y="6355080"/>
+            <a:ext cx="1828800" cy="457200"/>
+          </a:xfrm>
+          <a:prstGeom prst="rect">
+            <a:avLst/>
+          </a:prstGeom>
+          <a:noFill/>
+        </p:spPr>
+        <p:txBody>
+          <a:bodyPr wrap="square">
+            <a:spAutoFit/>
+          </a:bodyPr>
+          <a:lstStyle/>
+          <a:p>
+            <a:pPr algn="l">
+              <a:defRPr sz="1200" b="0">
+                <a:solidFill>
+                  <a:srgbClr val="FFDB15"/>
+                </a:solidFill>
+                <a:latin typeface="Arial"/>
+              </a:defRPr>
+            </a:pPr>
+            <a:r>
+              <a:t>User-only ✓</a:t>
+            </a:r>
+          </a:p>
+        </p:txBody>
+      </p:sp>
+      <p:sp>
+        <p:nvSpPr>
+          <p:cNvPr id="34" name="TextBox 33"/>
           <p:cNvSpPr txBox="1"/>
           <p:nvPr/>
         </p:nvSpPr>
@@ -9121,7 +9694,7 @@
             <a:pPr algn="r">
               <a:defRPr sz="1100" b="0">
                 <a:solidFill>
-                  <a:srgbClr val="FFDB15"/>
+                  <a:srgbClr val="646464"/>
                 </a:solidFill>
                 <a:latin typeface="Consolas"/>
               </a:defRPr>
@@ -9165,7 +9738,7 @@
             <a:avLst/>
           </a:prstGeom>
           <a:solidFill>
-            <a:srgbClr val="FFDB15"/>
+            <a:srgbClr val="000000"/>
           </a:solidFill>
           <a:ln>
             <a:noFill/>
@@ -9218,27 +9791,63 @@
             <a:pPr algn="l">
               <a:defRPr sz="4800" b="1">
                 <a:solidFill>
-                  <a:srgbClr val="000000"/>
+                  <a:srgbClr val="FFFFFF"/>
                 </a:solidFill>
                 <a:latin typeface="Arial"/>
               </a:defRPr>
             </a:pPr>
             <a:r>
-              <a:t>Status &amp; roadmap</a:t>
-            </a:r>
-          </a:p>
-        </p:txBody>
-      </p:sp>
-      <p:sp>
-        <p:nvSpPr>
-          <p:cNvPr id="4" name="Rounded Rectangle 3"/>
+              <a:t>Developer experience</a:t>
+            </a:r>
+          </a:p>
+        </p:txBody>
+      </p:sp>
+      <p:sp>
+        <p:nvSpPr>
+          <p:cNvPr id="4" name="TextBox 3"/>
+          <p:cNvSpPr txBox="1"/>
+          <p:nvPr/>
+        </p:nvSpPr>
+        <p:spPr>
+          <a:xfrm>
+            <a:off x="1097280" y="2377440"/>
+            <a:ext cx="9144000" cy="548640"/>
+          </a:xfrm>
+          <a:prstGeom prst="rect">
+            <a:avLst/>
+          </a:prstGeom>
+          <a:noFill/>
+        </p:spPr>
+        <p:txBody>
+          <a:bodyPr wrap="square">
+            <a:spAutoFit/>
+          </a:bodyPr>
+          <a:lstStyle/>
+          <a:p>
+            <a:pPr algn="l">
+              <a:defRPr sz="2000" b="0">
+                <a:solidFill>
+                  <a:srgbClr val="646464"/>
+                </a:solidFill>
+                <a:latin typeface="Arial"/>
+              </a:defRPr>
+            </a:pPr>
+            <a:r>
+              <a:t>Memory should feel automatic. Integration in minutes.</a:t>
+            </a:r>
+          </a:p>
+        </p:txBody>
+      </p:sp>
+      <p:sp>
+        <p:nvSpPr>
+          <p:cNvPr id="5" name="Rounded Rectangle 4"/>
           <p:cNvSpPr/>
           <p:nvPr/>
         </p:nvSpPr>
         <p:spPr>
           <a:xfrm>
-            <a:off x="1097280" y="2743200"/>
-            <a:ext cx="6400800" cy="4114800"/>
+            <a:off x="1097280" y="3200400"/>
+            <a:ext cx="6400800" cy="3657600"/>
           </a:xfrm>
           <a:prstGeom prst="roundRect">
             <a:avLst>
@@ -9246,10 +9855,12 @@
             </a:avLst>
           </a:prstGeom>
           <a:solidFill>
-            <a:srgbClr val="000000"/>
+            <a:srgbClr val="1E1E1E"/>
           </a:solidFill>
-          <a:ln>
-            <a:noFill/>
+          <a:ln w="25400">
+            <a:solidFill>
+              <a:srgbClr val="FFDB15"/>
+            </a:solidFill>
           </a:ln>
         </p:spPr>
         <p:style>
@@ -9276,13 +9887,13 @@
       </p:sp>
       <p:sp>
         <p:nvSpPr>
-          <p:cNvPr id="5" name="TextBox 4"/>
-          <p:cNvSpPr txBox="1"/>
-          <p:nvPr/>
-        </p:nvSpPr>
-        <p:spPr>
-          <a:xfrm>
-            <a:off x="1371600" y="2926080"/>
+          <p:cNvPr id="6" name="TextBox 5"/>
+          <p:cNvSpPr txBox="1"/>
+          <p:nvPr/>
+        </p:nvSpPr>
+        <p:spPr>
+          <a:xfrm>
+            <a:off x="1371600" y="3383280"/>
             <a:ext cx="5486400" cy="457200"/>
           </a:xfrm>
           <a:prstGeom prst="rect">
@@ -9305,89 +9916,89 @@
               </a:defRPr>
             </a:pPr>
             <a:r>
-              <a:t>Live in production</a:t>
-            </a:r>
-          </a:p>
-        </p:txBody>
-      </p:sp>
-      <p:sp>
-        <p:nvSpPr>
-          <p:cNvPr id="6" name="TextBox 5"/>
-          <p:cNvSpPr txBox="1"/>
-          <p:nvPr/>
-        </p:nvSpPr>
-        <p:spPr>
-          <a:xfrm>
-            <a:off x="1371600" y="3474720"/>
-            <a:ext cx="5943600" cy="3200400"/>
-          </a:xfrm>
-          <a:prstGeom prst="rect">
-            <a:avLst/>
-          </a:prstGeom>
-          <a:noFill/>
-        </p:spPr>
-        <p:txBody>
-          <a:bodyPr wrap="square">
-            <a:spAutoFit/>
-          </a:bodyPr>
-          <a:lstStyle/>
-          <a:p>
-            <a:pPr algn="l">
-              <a:defRPr sz="1300" b="0">
+              <a:t>Python SDK</a:t>
+            </a:r>
+          </a:p>
+        </p:txBody>
+      </p:sp>
+      <p:sp>
+        <p:nvSpPr>
+          <p:cNvPr id="7" name="TextBox 6"/>
+          <p:cNvSpPr txBox="1"/>
+          <p:nvPr/>
+        </p:nvSpPr>
+        <p:spPr>
+          <a:xfrm>
+            <a:off x="1371600" y="3931920"/>
+            <a:ext cx="5943600" cy="2743200"/>
+          </a:xfrm>
+          <a:prstGeom prst="rect">
+            <a:avLst/>
+          </a:prstGeom>
+          <a:noFill/>
+        </p:spPr>
+        <p:txBody>
+          <a:bodyPr wrap="square">
+            <a:spAutoFit/>
+          </a:bodyPr>
+          <a:lstStyle/>
+          <a:p>
+            <a:pPr algn="l">
+              <a:defRPr sz="1100" b="0">
                 <a:solidFill>
                   <a:srgbClr val="FFFFFF"/>
                 </a:solidFill>
-                <a:latin typeface="Arial"/>
-              </a:defRPr>
-            </a:pPr>
-            <a:r>
-              <a:t>✓ Core API (store, search, context)</a:t>
+                <a:latin typeface="Consolas"/>
+              </a:defRPr>
+            </a:pPr>
+            <a:r>
+              <a:t>from engrm import Engrm</a:t>
             </a:r>
             <a:br/>
-            <a:r>
-              <a:t>✓ Server-side encryption (AES-256-GCM)</a:t>
-            </a:r>
             <a:br/>
             <a:r>
-              <a:t>✓ Memory types &amp; classification</a:t>
+              <a:t>client = Engrm(api_key="mem_...")</a:t>
             </a:r>
             <a:br/>
-            <a:r>
-              <a:t>✓ Tiered importance system</a:t>
-            </a:r>
             <a:br/>
             <a:r>
-              <a:t>✓ Reflect, consolidate, decay</a:t>
+              <a:t># Store automatically</a:t>
             </a:r>
             <a:br/>
             <a:r>
-              <a:t>✓ Entity extraction &amp; linking</a:t>
+              <a:t>client.store("User loves hiking")</a:t>
             </a:r>
             <a:br/>
-            <a:r>
-              <a:t>✓ Memory Browser dashboard</a:t>
-            </a:r>
             <a:br/>
             <a:r>
-              <a:t>✓ Python SDK + MCP server</a:t>
+              <a:t># Recall with context</a:t>
             </a:r>
             <a:br/>
             <a:r>
-              <a:t>✓ LongMemEval benchmark integration</a:t>
-            </a:r>
-          </a:p>
-        </p:txBody>
-      </p:sp>
-      <p:sp>
-        <p:nvSpPr>
-          <p:cNvPr id="7" name="Rounded Rectangle 6"/>
+              <a:t>memories = client.search("outdoor activities")</a:t>
+            </a:r>
+            <a:br/>
+            <a:br/>
+            <a:r>
+              <a:t># Inject into prompt</a:t>
+            </a:r>
+            <a:br/>
+            <a:r>
+              <a:t>context = client.context()</a:t>
+            </a:r>
+          </a:p>
+        </p:txBody>
+      </p:sp>
+      <p:sp>
+        <p:nvSpPr>
+          <p:cNvPr id="8" name="Rounded Rectangle 7"/>
           <p:cNvSpPr/>
           <p:nvPr/>
         </p:nvSpPr>
         <p:spPr>
           <a:xfrm>
-            <a:off x="7955279" y="2743200"/>
-            <a:ext cx="5486400" cy="4114800"/>
+            <a:off x="7955279" y="3200400"/>
+            <a:ext cx="5760720" cy="3657600"/>
           </a:xfrm>
           <a:prstGeom prst="roundRect">
             <a:avLst>
@@ -9425,13 +10036,13 @@
       </p:sp>
       <p:sp>
         <p:nvSpPr>
-          <p:cNvPr id="8" name="TextBox 7"/>
-          <p:cNvSpPr txBox="1"/>
-          <p:nvPr/>
-        </p:nvSpPr>
-        <p:spPr>
-          <a:xfrm>
-            <a:off x="8229600" y="2926080"/>
+          <p:cNvPr id="9" name="TextBox 8"/>
+          <p:cNvSpPr txBox="1"/>
+          <p:nvPr/>
+        </p:nvSpPr>
+        <p:spPr>
+          <a:xfrm>
+            <a:off x="8229600" y="3383280"/>
             <a:ext cx="5029200" cy="457200"/>
           </a:xfrm>
           <a:prstGeom prst="rect">
@@ -9454,21 +10065,21 @@
               </a:defRPr>
             </a:pPr>
             <a:r>
-              <a:t>Next 90 days</a:t>
-            </a:r>
-          </a:p>
-        </p:txBody>
-      </p:sp>
-      <p:sp>
-        <p:nvSpPr>
-          <p:cNvPr id="9" name="TextBox 8"/>
-          <p:cNvSpPr txBox="1"/>
-          <p:nvPr/>
-        </p:nvSpPr>
-        <p:spPr>
-          <a:xfrm>
-            <a:off x="8229600" y="3474720"/>
-            <a:ext cx="5029200" cy="3200400"/>
+              <a:t>What you get</a:t>
+            </a:r>
+          </a:p>
+        </p:txBody>
+      </p:sp>
+      <p:sp>
+        <p:nvSpPr>
+          <p:cNvPr id="10" name="TextBox 9"/>
+          <p:cNvSpPr txBox="1"/>
+          <p:nvPr/>
+        </p:nvSpPr>
+        <p:spPr>
+          <a:xfrm>
+            <a:off x="8229600" y="3931920"/>
+            <a:ext cx="5303520" cy="2743200"/>
           </a:xfrm>
           <a:prstGeom prst="rect">
             <a:avLst/>
@@ -9490,38 +10101,42 @@
               </a:defRPr>
             </a:pPr>
             <a:r>
-              <a:t>→ LangChain integration</a:t>
+              <a:t>✓ Auto memory classification</a:t>
             </a:r>
             <a:br/>
             <a:r>
-              <a:t>→ OpenAI Agents SDK adapter</a:t>
+              <a:t>✓ Entity extraction included</a:t>
             </a:r>
             <a:br/>
             <a:r>
-              <a:t>→ Proactive recall (auto-surface)</a:t>
+              <a:t>✓ Semantic + keyword search</a:t>
             </a:r>
             <a:br/>
             <a:r>
-              <a:t>→ Contradiction detection</a:t>
+              <a:t>✓ Token-optimized context</a:t>
             </a:r>
             <a:br/>
             <a:r>
-              <a:t>→ Multi-agent memory sharing</a:t>
+              <a:t>✓ Memory Browser dashboard</a:t>
             </a:r>
             <a:br/>
             <a:r>
-              <a:t>→ Enterprise SSO + audit logs</a:t>
+              <a:t>✓ Usage analytics</a:t>
             </a:r>
             <a:br/>
             <a:r>
-              <a:t>→ On-prem deployment option</a:t>
-            </a:r>
-          </a:p>
-        </p:txBody>
-      </p:sp>
-      <p:sp>
-        <p:nvSpPr>
-          <p:cNvPr id="10" name="TextBox 9"/>
+              <a:t>✓ MCP server for Claude</a:t>
+            </a:r>
+            <a:br/>
+            <a:r>
+              <a:t>✓ REST API + TypeScript SDK</a:t>
+            </a:r>
+          </a:p>
+        </p:txBody>
+      </p:sp>
+      <p:sp>
+        <p:nvSpPr>
+          <p:cNvPr id="11" name="TextBox 10"/>
           <p:cNvSpPr txBox="1"/>
           <p:nvPr/>
         </p:nvSpPr>
@@ -9544,7 +10159,7 @@
             <a:pPr algn="r">
               <a:defRPr sz="1100" b="0">
                 <a:solidFill>
-                  <a:srgbClr val="646464"/>
+                  <a:srgbClr val="FFDB15"/>
                 </a:solidFill>
                 <a:latin typeface="Consolas"/>
               </a:defRPr>

</xml_diff>

<commit_message>
deck: replace Python SDK with OpenClaw plugin install
- Shows real, working integration (not aspirational SDK)
- 3 commands to install + configure
- Updated 'What you get' with auto-recall, auto-capture, cross-channel
</commit_message>
<xml_diff>
--- a/Engrm-Pitch-Deck-v3.pptx
+++ b/Engrm-Pitch-Deck-v3.pptx
@@ -9916,7 +9916,7 @@
               </a:defRPr>
             </a:pPr>
             <a:r>
-              <a:t>Python SDK</a:t>
+              <a:t>OpenClaw Plugin</a:t>
             </a:r>
           </a:p>
         </p:txBody>
@@ -9952,39 +9952,41 @@
               </a:defRPr>
             </a:pPr>
             <a:r>
-              <a:t>from engrm import Engrm</a:t>
+              <a:t># Install the plugin</a:t>
+            </a:r>
+            <a:br/>
+            <a:r>
+              <a:t>openclaw plugins install @engrm/memory</a:t>
             </a:r>
             <a:br/>
             <a:br/>
             <a:r>
-              <a:t>client = Engrm(api_key="mem_...")</a:t>
+              <a:t># Configure</a:t>
+            </a:r>
+            <a:br/>
+            <a:r>
+              <a:t>openclaw config set \</a:t>
+            </a:r>
+            <a:br/>
+            <a:r>
+              <a:t>  plugins.slots.memory=memory-engrm</a:t>
+            </a:r>
+            <a:br/>
+            <a:r>
+              <a:t>openclaw config set \</a:t>
+            </a:r>
+            <a:br/>
+            <a:r>
+              <a:t>  plugins.entries.memory-engrm.\</a:t>
+            </a:r>
+            <a:br/>
+            <a:r>
+              <a:t>  config.apiKey=mem_xxx</a:t>
             </a:r>
             <a:br/>
             <a:br/>
             <a:r>
-              <a:t># Store automatically</a:t>
-            </a:r>
-            <a:br/>
-            <a:r>
-              <a:t>client.store("User loves hiking")</a:t>
-            </a:r>
-            <a:br/>
-            <a:br/>
-            <a:r>
-              <a:t># Recall with context</a:t>
-            </a:r>
-            <a:br/>
-            <a:r>
-              <a:t>memories = client.search("outdoor activities")</a:t>
-            </a:r>
-            <a:br/>
-            <a:br/>
-            <a:r>
-              <a:t># Inject into prompt</a:t>
-            </a:r>
-            <a:br/>
-            <a:r>
-              <a:t>context = client.context()</a:t>
+              <a:t># Done. Memory is automatic.</a:t>
             </a:r>
           </a:p>
         </p:txBody>
@@ -10101,35 +10103,35 @@
               </a:defRPr>
             </a:pPr>
             <a:r>
-              <a:t>✓ Auto memory classification</a:t>
+              <a:t>✓ Auto-recall at session start</a:t>
             </a:r>
             <a:br/>
             <a:r>
-              <a:t>✓ Entity extraction included</a:t>
+              <a:t>✓ Auto-capture after conversations</a:t>
             </a:r>
             <a:br/>
             <a:r>
-              <a:t>✓ Semantic + keyword search</a:t>
+              <a:t>✓ Works across all chat channels</a:t>
             </a:r>
             <a:br/>
             <a:r>
-              <a:t>✓ Token-optimized context</a:t>
+              <a:t>✓ Survives model switches</a:t>
             </a:r>
             <a:br/>
             <a:r>
+              <a:t>✓ Cloud-native (cross-device)</a:t>
+            </a:r>
+            <a:br/>
+            <a:r>
+              <a:t>✓ Encrypted at rest (AES-256)</a:t>
+            </a:r>
+            <a:br/>
+            <a:r>
               <a:t>✓ Memory Browser dashboard</a:t>
             </a:r>
             <a:br/>
             <a:r>
-              <a:t>✓ Usage analytics</a:t>
-            </a:r>
-            <a:br/>
-            <a:r>
-              <a:t>✓ MCP server for Claude</a:t>
-            </a:r>
-            <a:br/>
-            <a:r>
-              <a:t>✓ REST API + TypeScript SDK</a:t>
+              <a:t>✓ REST API available</a:t>
             </a:r>
           </a:p>
         </p:txBody>

</xml_diff>